<commit_message>
feat(slides): regenera los 8 decks del instructor con el diseno v2
Aplica el mismo rediseno estetico de las infografias (slides/lib.js):
tarjetas/paneles redondeados con sombra y divisor, paneles de codigo con
chrome de terminal, pasos con flechas de flujo, titulos con subrayado de
acento y cuadros decorativos. Hereda tambien el fix de la sombra mutada
(ya no se corrompen los PPTX).

Regenerados: 01-04 Dia (ES) + 01-04 Day (EN). Verificado: abre en
PowerPoint, 38 sombras 0 corruptas, 15 laminas exportadas en QA.

Co-Authored-By: Claude Opus 4.8 (1M context) <noreply@anthropic.com>
</commit_message>
<xml_diff>
--- a/slides/01_Day_1_DevOps_Docker.pptx
+++ b/slides/01_Day_1_DevOps_Docker.pptx
@@ -2103,7 +2103,7 @@
     <p:bg>
       <p:bgPr>
         <a:solidFill>
-          <a:srgbClr val="0B1B2B"/>
+          <a:srgbClr val="0A1622"/>
         </a:solidFill>
       </p:bgPr>
     </p:bg>
@@ -2141,6 +2141,13 @@
             <a:srgbClr val="22D3EE"/>
           </a:solidFill>
           <a:ln/>
+          <a:effectLst>
+            <a:outerShdw sx="100000" sy="100000" kx="0" ky="0" algn="bl" rotWithShape="0" blurRad="50800" dist="25400" dir="5400000">
+              <a:srgbClr val="000000">
+                <a:alpha val="40000"/>
+              </a:srgbClr>
+            </a:outerShdw>
+          </a:effectLst>
         </p:spPr>
       </p:sp>
       <p:sp>
@@ -2288,7 +2295,27 @@
       </p:sp>
       <p:sp>
         <p:nvSpPr>
-          <p:cNvPr id="7" name="Text 5"/>
+          <p:cNvPr id="7" name="Shape 5"/>
+          <p:cNvSpPr/>
+          <p:nvPr/>
+        </p:nvSpPr>
+        <p:spPr>
+          <a:xfrm>
+            <a:off x="566928" y="3154680"/>
+            <a:ext cx="1280160" cy="36576"/>
+          </a:xfrm>
+          <a:prstGeom prst="rect">
+            <a:avLst/>
+          </a:prstGeom>
+          <a:solidFill>
+            <a:srgbClr val="22D3EE"/>
+          </a:solidFill>
+          <a:ln/>
+        </p:spPr>
+      </p:sp>
+      <p:sp>
+        <p:nvSpPr>
+          <p:cNvPr id="8" name="Text 6"/>
           <p:cNvSpPr/>
           <p:nvPr/>
         </p:nvSpPr>
@@ -2313,7 +2340,7 @@
             <a:r>
               <a:rPr lang="en-US" sz="1700" dirty="0">
                 <a:solidFill>
-                  <a:srgbClr val="A8B4C4"/>
+                  <a:srgbClr val="9FB0C2"/>
                 </a:solidFill>
                 <a:latin typeface="Calibri" pitchFamily="34" charset="0"/>
                 <a:ea typeface="Calibri" pitchFamily="34" charset="-122"/>
@@ -2327,7 +2354,7 @@
       </p:sp>
       <p:sp>
         <p:nvSpPr>
-          <p:cNvPr id="8" name="Shape 6"/>
+          <p:cNvPr id="9" name="Shape 7"/>
           <p:cNvSpPr/>
           <p:nvPr/>
         </p:nvSpPr>
@@ -2340,14 +2367,14 @@
             <a:avLst/>
           </a:prstGeom>
           <a:solidFill>
-            <a:srgbClr val="284963"/>
-          </a:solidFill>
-          <a:ln/>
-        </p:spPr>
-      </p:sp>
-      <p:sp>
-        <p:nvSpPr>
-          <p:cNvPr id="9" name="Text 7"/>
+            <a:srgbClr val="264862"/>
+          </a:solidFill>
+          <a:ln/>
+        </p:spPr>
+      </p:sp>
+      <p:sp>
+        <p:nvSpPr>
+          <p:cNvPr id="10" name="Text 8"/>
           <p:cNvSpPr/>
           <p:nvPr/>
         </p:nvSpPr>
@@ -2372,7 +2399,7 @@
             <a:r>
               <a:rPr lang="en-US" sz="1200" dirty="0">
                 <a:solidFill>
-                  <a:srgbClr val="A8B4C4"/>
+                  <a:srgbClr val="9FB0C2"/>
                 </a:solidFill>
                 <a:latin typeface="Consolas" pitchFamily="34" charset="0"/>
                 <a:ea typeface="Consolas" pitchFamily="34" charset="-122"/>
@@ -2398,7 +2425,7 @@
     <p:bg>
       <p:bgPr>
         <a:solidFill>
-          <a:srgbClr val="0B1B2B"/>
+          <a:srgbClr val="0A1622"/>
         </a:solidFill>
       </p:bgPr>
     </p:bg>
@@ -2436,6 +2463,13 @@
             <a:srgbClr val="22D3EE"/>
           </a:solidFill>
           <a:ln/>
+          <a:effectLst>
+            <a:outerShdw sx="100000" sy="100000" kx="0" ky="0" algn="bl" rotWithShape="0" blurRad="50800" dist="25400" dir="5400000">
+              <a:srgbClr val="000000">
+                <a:alpha val="40000"/>
+              </a:srgbClr>
+            </a:outerShdw>
+          </a:effectLst>
         </p:spPr>
       </p:sp>
       <p:sp>
@@ -2465,7 +2499,7 @@
             <a:r>
               <a:rPr lang="en-US" sz="2200" b="1" dirty="0">
                 <a:solidFill>
-                  <a:srgbClr val="0B1B2B"/>
+                  <a:srgbClr val="0A1622"/>
                 </a:solidFill>
                 <a:latin typeface="Consolas" pitchFamily="34" charset="0"/>
                 <a:ea typeface="Consolas" pitchFamily="34" charset="-122"/>
@@ -2563,14 +2597,36 @@
         </p:nvSpPr>
         <p:spPr>
           <a:xfrm>
+            <a:off x="1298448" y="1316736"/>
+            <a:ext cx="1005840" cy="32004"/>
+          </a:xfrm>
+          <a:prstGeom prst="rect">
+            <a:avLst/>
+          </a:prstGeom>
+          <a:solidFill>
+            <a:srgbClr val="22D3EE"/>
+          </a:solidFill>
+          <a:ln/>
+        </p:spPr>
+      </p:sp>
+      <p:sp>
+        <p:nvSpPr>
+          <p:cNvPr id="7" name="Shape 5"/>
+          <p:cNvSpPr/>
+          <p:nvPr/>
+        </p:nvSpPr>
+        <p:spPr>
+          <a:xfrm>
             <a:off x="548640" y="1691640"/>
             <a:ext cx="3886200" cy="2743200"/>
           </a:xfrm>
-          <a:prstGeom prst="rect">
-            <a:avLst/>
-          </a:prstGeom>
-          <a:solidFill>
-            <a:srgbClr val="12293D"/>
+          <a:prstGeom prst="roundRect">
+            <a:avLst>
+              <a:gd name="adj" fmla="val 1667"/>
+            </a:avLst>
+          </a:prstGeom>
+          <a:solidFill>
+            <a:srgbClr val="13283C"/>
           </a:solidFill>
           <a:ln w="15875">
             <a:solidFill>
@@ -2578,18 +2634,25 @@
             </a:solidFill>
             <a:prstDash val="solid"/>
           </a:ln>
-        </p:spPr>
-      </p:sp>
-      <p:sp>
-        <p:nvSpPr>
-          <p:cNvPr id="7" name="Shape 5"/>
-          <p:cNvSpPr/>
-          <p:nvPr/>
-        </p:nvSpPr>
-        <p:spPr>
-          <a:xfrm>
-            <a:off x="548640" y="1691640"/>
-            <a:ext cx="82296" cy="2743200"/>
+          <a:effectLst>
+            <a:outerShdw sx="100000" sy="100000" kx="0" ky="0" algn="bl" rotWithShape="0" blurRad="88900" dist="38100" dir="5400000">
+              <a:srgbClr val="000000">
+                <a:alpha val="50000"/>
+              </a:srgbClr>
+            </a:outerShdw>
+          </a:effectLst>
+        </p:spPr>
+      </p:sp>
+      <p:sp>
+        <p:nvSpPr>
+          <p:cNvPr id="8" name="Shape 6"/>
+          <p:cNvSpPr/>
+          <p:nvPr/>
+        </p:nvSpPr>
+        <p:spPr>
+          <a:xfrm>
+            <a:off x="562356" y="1764792"/>
+            <a:ext cx="73152" cy="2596896"/>
           </a:xfrm>
           <a:prstGeom prst="rect">
             <a:avLst/>
@@ -2602,14 +2665,14 @@
       </p:sp>
       <p:sp>
         <p:nvSpPr>
-          <p:cNvPr id="8" name="Text 6"/>
-          <p:cNvSpPr/>
-          <p:nvPr/>
-        </p:nvSpPr>
-        <p:spPr>
-          <a:xfrm>
-            <a:off x="786384" y="1837944"/>
-            <a:ext cx="3502152" cy="384048"/>
+          <p:cNvPr id="9" name="Text 7"/>
+          <p:cNvSpPr/>
+          <p:nvPr/>
+        </p:nvSpPr>
+        <p:spPr>
+          <a:xfrm>
+            <a:off x="804672" y="1828800"/>
+            <a:ext cx="3483864" cy="384048"/>
           </a:xfrm>
           <a:prstGeom prst="rect">
             <a:avLst/>
@@ -2625,7 +2688,7 @@
               <a:buNone/>
             </a:pPr>
             <a:r>
-              <a:rPr lang="en-US" sz="1500" b="1" dirty="0">
+              <a:rPr lang="en-US" sz="1500" b="1" spc="50" kern="0" dirty="0">
                 <a:solidFill>
                   <a:srgbClr val="34D399"/>
                 </a:solidFill>
@@ -2641,14 +2704,34 @@
       </p:sp>
       <p:sp>
         <p:nvSpPr>
-          <p:cNvPr id="9" name="Text 7"/>
-          <p:cNvSpPr/>
-          <p:nvPr/>
-        </p:nvSpPr>
-        <p:spPr>
-          <a:xfrm>
-            <a:off x="786384" y="2276856"/>
-            <a:ext cx="3429000" cy="2011680"/>
+          <p:cNvPr id="10" name="Shape 8"/>
+          <p:cNvSpPr/>
+          <p:nvPr/>
+        </p:nvSpPr>
+        <p:spPr>
+          <a:xfrm>
+            <a:off x="804672" y="2221992"/>
+            <a:ext cx="3374136" cy="16459"/>
+          </a:xfrm>
+          <a:prstGeom prst="rect">
+            <a:avLst/>
+          </a:prstGeom>
+          <a:solidFill>
+            <a:srgbClr val="264862"/>
+          </a:solidFill>
+          <a:ln/>
+        </p:spPr>
+      </p:sp>
+      <p:sp>
+        <p:nvSpPr>
+          <p:cNvPr id="11" name="Text 9"/>
+          <p:cNvSpPr/>
+          <p:nvPr/>
+        </p:nvSpPr>
+        <p:spPr>
+          <a:xfrm>
+            <a:off x="804672" y="2331720"/>
+            <a:ext cx="3410712" cy="1956816"/>
           </a:xfrm>
           <a:prstGeom prst="rect">
             <a:avLst/>
@@ -2670,7 +2753,7 @@
             <a:r>
               <a:rPr lang="en-US" sz="1250" dirty="0">
                 <a:solidFill>
-                  <a:srgbClr val="E8EEF5"/>
+                  <a:srgbClr val="EAF1F8"/>
                 </a:solidFill>
                 <a:latin typeface="Calibri" pitchFamily="34" charset="0"/>
                 <a:ea typeface="Calibri" pitchFamily="34" charset="-122"/>
@@ -2691,7 +2774,7 @@
             <a:r>
               <a:rPr lang="en-US" sz="1250" dirty="0">
                 <a:solidFill>
-                  <a:srgbClr val="E8EEF5"/>
+                  <a:srgbClr val="EAF1F8"/>
                 </a:solidFill>
                 <a:latin typeface="Calibri" pitchFamily="34" charset="0"/>
                 <a:ea typeface="Calibri" pitchFamily="34" charset="-122"/>
@@ -2712,7 +2795,7 @@
             <a:r>
               <a:rPr lang="en-US" sz="1250" dirty="0">
                 <a:solidFill>
-                  <a:srgbClr val="E8EEF5"/>
+                  <a:srgbClr val="EAF1F8"/>
                 </a:solidFill>
                 <a:latin typeface="Calibri" pitchFamily="34" charset="0"/>
                 <a:ea typeface="Calibri" pitchFamily="34" charset="-122"/>
@@ -2733,7 +2816,7 @@
             <a:r>
               <a:rPr lang="en-US" sz="1250" dirty="0">
                 <a:solidFill>
-                  <a:srgbClr val="E8EEF5"/>
+                  <a:srgbClr val="EAF1F8"/>
                 </a:solidFill>
                 <a:latin typeface="Calibri" pitchFamily="34" charset="0"/>
                 <a:ea typeface="Calibri" pitchFamily="34" charset="-122"/>
@@ -2747,7 +2830,7 @@
       </p:sp>
       <p:sp>
         <p:nvSpPr>
-          <p:cNvPr id="10" name="Shape 8"/>
+          <p:cNvPr id="12" name="Shape 10"/>
           <p:cNvSpPr/>
           <p:nvPr/>
         </p:nvSpPr>
@@ -2756,50 +2839,59 @@
             <a:off x="4663440" y="1691640"/>
             <a:ext cx="3931920" cy="2743200"/>
           </a:xfrm>
-          <a:prstGeom prst="rect">
-            <a:avLst/>
-          </a:prstGeom>
-          <a:solidFill>
-            <a:srgbClr val="12293D"/>
+          <a:prstGeom prst="roundRect">
+            <a:avLst>
+              <a:gd name="adj" fmla="val 1667"/>
+            </a:avLst>
+          </a:prstGeom>
+          <a:solidFill>
+            <a:srgbClr val="13283C"/>
           </a:solidFill>
           <a:ln w="15875">
             <a:solidFill>
-              <a:srgbClr val="A8B4C4"/>
+              <a:srgbClr val="9FB0C2"/>
             </a:solidFill>
             <a:prstDash val="solid"/>
           </a:ln>
-        </p:spPr>
-      </p:sp>
-      <p:sp>
-        <p:nvSpPr>
-          <p:cNvPr id="11" name="Shape 9"/>
-          <p:cNvSpPr/>
-          <p:nvPr/>
-        </p:nvSpPr>
-        <p:spPr>
-          <a:xfrm>
-            <a:off x="4663440" y="1691640"/>
-            <a:ext cx="82296" cy="2743200"/>
-          </a:xfrm>
-          <a:prstGeom prst="rect">
-            <a:avLst/>
-          </a:prstGeom>
-          <a:solidFill>
-            <a:srgbClr val="A8B4C4"/>
-          </a:solidFill>
-          <a:ln/>
-        </p:spPr>
-      </p:sp>
-      <p:sp>
-        <p:nvSpPr>
-          <p:cNvPr id="12" name="Text 10"/>
-          <p:cNvSpPr/>
-          <p:nvPr/>
-        </p:nvSpPr>
-        <p:spPr>
-          <a:xfrm>
-            <a:off x="4901184" y="1837944"/>
-            <a:ext cx="3547872" cy="384048"/>
+          <a:effectLst>
+            <a:outerShdw sx="100000" sy="100000" kx="0" ky="0" algn="bl" rotWithShape="0" blurRad="88900" dist="38100" dir="5400000">
+              <a:srgbClr val="000000">
+                <a:alpha val="50000"/>
+              </a:srgbClr>
+            </a:outerShdw>
+          </a:effectLst>
+        </p:spPr>
+      </p:sp>
+      <p:sp>
+        <p:nvSpPr>
+          <p:cNvPr id="13" name="Shape 11"/>
+          <p:cNvSpPr/>
+          <p:nvPr/>
+        </p:nvSpPr>
+        <p:spPr>
+          <a:xfrm>
+            <a:off x="4677156" y="1764792"/>
+            <a:ext cx="73152" cy="2596896"/>
+          </a:xfrm>
+          <a:prstGeom prst="rect">
+            <a:avLst/>
+          </a:prstGeom>
+          <a:solidFill>
+            <a:srgbClr val="9FB0C2"/>
+          </a:solidFill>
+          <a:ln/>
+        </p:spPr>
+      </p:sp>
+      <p:sp>
+        <p:nvSpPr>
+          <p:cNvPr id="14" name="Text 12"/>
+          <p:cNvSpPr/>
+          <p:nvPr/>
+        </p:nvSpPr>
+        <p:spPr>
+          <a:xfrm>
+            <a:off x="4919472" y="1828800"/>
+            <a:ext cx="3529584" cy="384048"/>
           </a:xfrm>
           <a:prstGeom prst="rect">
             <a:avLst/>
@@ -2815,9 +2907,9 @@
               <a:buNone/>
             </a:pPr>
             <a:r>
-              <a:rPr lang="en-US" sz="1500" b="1" dirty="0">
-                <a:solidFill>
-                  <a:srgbClr val="A8B4C4"/>
+              <a:rPr lang="en-US" sz="1500" b="1" spc="50" kern="0" dirty="0">
+                <a:solidFill>
+                  <a:srgbClr val="9FB0C2"/>
                 </a:solidFill>
                 <a:latin typeface="Trebuchet MS" pitchFamily="34" charset="0"/>
                 <a:ea typeface="Trebuchet MS" pitchFamily="34" charset="-122"/>
@@ -2831,14 +2923,34 @@
       </p:sp>
       <p:sp>
         <p:nvSpPr>
-          <p:cNvPr id="13" name="Text 11"/>
-          <p:cNvSpPr/>
-          <p:nvPr/>
-        </p:nvSpPr>
-        <p:spPr>
-          <a:xfrm>
-            <a:off x="4901184" y="2276856"/>
-            <a:ext cx="3474720" cy="2011680"/>
+          <p:cNvPr id="15" name="Shape 13"/>
+          <p:cNvSpPr/>
+          <p:nvPr/>
+        </p:nvSpPr>
+        <p:spPr>
+          <a:xfrm>
+            <a:off x="4919472" y="2221992"/>
+            <a:ext cx="3419856" cy="16459"/>
+          </a:xfrm>
+          <a:prstGeom prst="rect">
+            <a:avLst/>
+          </a:prstGeom>
+          <a:solidFill>
+            <a:srgbClr val="264862"/>
+          </a:solidFill>
+          <a:ln/>
+        </p:spPr>
+      </p:sp>
+      <p:sp>
+        <p:nvSpPr>
+          <p:cNvPr id="16" name="Text 14"/>
+          <p:cNvSpPr/>
+          <p:nvPr/>
+        </p:nvSpPr>
+        <p:spPr>
+          <a:xfrm>
+            <a:off x="4919472" y="2331720"/>
+            <a:ext cx="3456432" cy="1956816"/>
           </a:xfrm>
           <a:prstGeom prst="rect">
             <a:avLst/>
@@ -2860,7 +2972,7 @@
             <a:r>
               <a:rPr lang="en-US" sz="1250" dirty="0">
                 <a:solidFill>
-                  <a:srgbClr val="E8EEF5"/>
+                  <a:srgbClr val="EAF1F8"/>
                 </a:solidFill>
                 <a:latin typeface="Calibri" pitchFamily="34" charset="0"/>
                 <a:ea typeface="Calibri" pitchFamily="34" charset="-122"/>
@@ -2881,7 +2993,7 @@
             <a:r>
               <a:rPr lang="en-US" sz="1250" dirty="0">
                 <a:solidFill>
-                  <a:srgbClr val="E8EEF5"/>
+                  <a:srgbClr val="EAF1F8"/>
                 </a:solidFill>
                 <a:latin typeface="Calibri" pitchFamily="34" charset="0"/>
                 <a:ea typeface="Calibri" pitchFamily="34" charset="-122"/>
@@ -2902,7 +3014,7 @@
             <a:r>
               <a:rPr lang="en-US" sz="1250" dirty="0">
                 <a:solidFill>
-                  <a:srgbClr val="E8EEF5"/>
+                  <a:srgbClr val="EAF1F8"/>
                 </a:solidFill>
                 <a:latin typeface="Calibri" pitchFamily="34" charset="0"/>
                 <a:ea typeface="Calibri" pitchFamily="34" charset="-122"/>
@@ -2923,7 +3035,7 @@
             <a:r>
               <a:rPr lang="en-US" sz="1250" dirty="0">
                 <a:solidFill>
-                  <a:srgbClr val="E8EEF5"/>
+                  <a:srgbClr val="EAF1F8"/>
                 </a:solidFill>
                 <a:latin typeface="Calibri" pitchFamily="34" charset="0"/>
                 <a:ea typeface="Calibri" pitchFamily="34" charset="-122"/>
@@ -2949,7 +3061,7 @@
     <p:bg>
       <p:bgPr>
         <a:solidFill>
-          <a:srgbClr val="0B1B2B"/>
+          <a:srgbClr val="0A1622"/>
         </a:solidFill>
       </p:bgPr>
     </p:bg>
@@ -2987,6 +3099,13 @@
             <a:srgbClr val="22D3EE"/>
           </a:solidFill>
           <a:ln/>
+          <a:effectLst>
+            <a:outerShdw sx="100000" sy="100000" kx="0" ky="0" algn="bl" rotWithShape="0" blurRad="50800" dist="25400" dir="5400000">
+              <a:srgbClr val="000000">
+                <a:alpha val="40000"/>
+              </a:srgbClr>
+            </a:outerShdw>
+          </a:effectLst>
         </p:spPr>
       </p:sp>
       <p:sp>
@@ -3016,7 +3135,7 @@
             <a:r>
               <a:rPr lang="en-US" sz="2200" b="1" dirty="0">
                 <a:solidFill>
-                  <a:srgbClr val="0B1B2B"/>
+                  <a:srgbClr val="0A1622"/>
                 </a:solidFill>
                 <a:latin typeface="Consolas" pitchFamily="34" charset="0"/>
                 <a:ea typeface="Consolas" pitchFamily="34" charset="-122"/>
@@ -3114,33 +3233,142 @@
         </p:nvSpPr>
         <p:spPr>
           <a:xfrm>
+            <a:off x="1298448" y="1316736"/>
+            <a:ext cx="1005840" cy="32004"/>
+          </a:xfrm>
+          <a:prstGeom prst="rect">
+            <a:avLst/>
+          </a:prstGeom>
+          <a:solidFill>
+            <a:srgbClr val="22D3EE"/>
+          </a:solidFill>
+          <a:ln/>
+        </p:spPr>
+      </p:sp>
+      <p:sp>
+        <p:nvSpPr>
+          <p:cNvPr id="7" name="Shape 5"/>
+          <p:cNvSpPr/>
+          <p:nvPr/>
+        </p:nvSpPr>
+        <p:spPr>
+          <a:xfrm>
             <a:off x="548640" y="1691640"/>
             <a:ext cx="8046720" cy="2834640"/>
           </a:xfrm>
-          <a:prstGeom prst="rect">
-            <a:avLst/>
-          </a:prstGeom>
-          <a:solidFill>
-            <a:srgbClr val="081320"/>
+          <a:prstGeom prst="roundRect">
+            <a:avLst>
+              <a:gd name="adj" fmla="val 1129"/>
+            </a:avLst>
+          </a:prstGeom>
+          <a:solidFill>
+            <a:srgbClr val="060F1A"/>
           </a:solidFill>
           <a:ln w="12700">
             <a:solidFill>
-              <a:srgbClr val="284963"/>
+              <a:srgbClr val="264862"/>
             </a:solidFill>
             <a:prstDash val="solid"/>
           </a:ln>
-        </p:spPr>
-      </p:sp>
-      <p:sp>
-        <p:nvSpPr>
-          <p:cNvPr id="7" name="Text 5"/>
-          <p:cNvSpPr/>
-          <p:nvPr/>
-        </p:nvSpPr>
-        <p:spPr>
-          <a:xfrm>
-            <a:off x="749808" y="1819656"/>
-            <a:ext cx="7644384" cy="2578608"/>
+          <a:effectLst>
+            <a:outerShdw sx="100000" sy="100000" kx="0" ky="0" algn="bl" rotWithShape="0" blurRad="88900" dist="38100" dir="5400000">
+              <a:srgbClr val="000000">
+                <a:alpha val="50000"/>
+              </a:srgbClr>
+            </a:outerShdw>
+          </a:effectLst>
+        </p:spPr>
+      </p:sp>
+      <p:sp>
+        <p:nvSpPr>
+          <p:cNvPr id="8" name="Shape 6"/>
+          <p:cNvSpPr/>
+          <p:nvPr/>
+        </p:nvSpPr>
+        <p:spPr>
+          <a:xfrm>
+            <a:off x="566928" y="1728216"/>
+            <a:ext cx="8010144" cy="274320"/>
+          </a:xfrm>
+          <a:prstGeom prst="rect">
+            <a:avLst/>
+          </a:prstGeom>
+          <a:solidFill>
+            <a:srgbClr val="13283C"/>
+          </a:solidFill>
+          <a:ln/>
+        </p:spPr>
+      </p:sp>
+      <p:sp>
+        <p:nvSpPr>
+          <p:cNvPr id="9" name="Shape 7"/>
+          <p:cNvSpPr/>
+          <p:nvPr/>
+        </p:nvSpPr>
+        <p:spPr>
+          <a:xfrm>
+            <a:off x="713232" y="1801368"/>
+            <a:ext cx="118872" cy="118872"/>
+          </a:xfrm>
+          <a:prstGeom prst="ellipse">
+            <a:avLst/>
+          </a:prstGeom>
+          <a:solidFill>
+            <a:srgbClr val="FB7185"/>
+          </a:solidFill>
+          <a:ln/>
+        </p:spPr>
+      </p:sp>
+      <p:sp>
+        <p:nvSpPr>
+          <p:cNvPr id="10" name="Shape 8"/>
+          <p:cNvSpPr/>
+          <p:nvPr/>
+        </p:nvSpPr>
+        <p:spPr>
+          <a:xfrm>
+            <a:off x="886968" y="1801368"/>
+            <a:ext cx="118872" cy="118872"/>
+          </a:xfrm>
+          <a:prstGeom prst="ellipse">
+            <a:avLst/>
+          </a:prstGeom>
+          <a:solidFill>
+            <a:srgbClr val="FBBF24"/>
+          </a:solidFill>
+          <a:ln/>
+        </p:spPr>
+      </p:sp>
+      <p:sp>
+        <p:nvSpPr>
+          <p:cNvPr id="11" name="Shape 9"/>
+          <p:cNvSpPr/>
+          <p:nvPr/>
+        </p:nvSpPr>
+        <p:spPr>
+          <a:xfrm>
+            <a:off x="1060704" y="1801368"/>
+            <a:ext cx="118872" cy="118872"/>
+          </a:xfrm>
+          <a:prstGeom prst="ellipse">
+            <a:avLst/>
+          </a:prstGeom>
+          <a:solidFill>
+            <a:srgbClr val="34D399"/>
+          </a:solidFill>
+          <a:ln/>
+        </p:spPr>
+      </p:sp>
+      <p:sp>
+        <p:nvSpPr>
+          <p:cNvPr id="12" name="Text 10"/>
+          <p:cNvSpPr/>
+          <p:nvPr/>
+        </p:nvSpPr>
+        <p:spPr>
+          <a:xfrm>
+            <a:off x="768096" y="2112264"/>
+            <a:ext cx="7626096" cy="2286000"/>
           </a:xfrm>
           <a:prstGeom prst="rect">
             <a:avLst/>
@@ -3303,7 +3531,7 @@
     <p:bg>
       <p:bgPr>
         <a:solidFill>
-          <a:srgbClr val="0B1B2B"/>
+          <a:srgbClr val="0A1622"/>
         </a:solidFill>
       </p:bgPr>
     </p:bg>
@@ -3341,6 +3569,13 @@
             <a:srgbClr val="22D3EE"/>
           </a:solidFill>
           <a:ln/>
+          <a:effectLst>
+            <a:outerShdw sx="100000" sy="100000" kx="0" ky="0" algn="bl" rotWithShape="0" blurRad="50800" dist="25400" dir="5400000">
+              <a:srgbClr val="000000">
+                <a:alpha val="40000"/>
+              </a:srgbClr>
+            </a:outerShdw>
+          </a:effectLst>
         </p:spPr>
       </p:sp>
       <p:sp>
@@ -3370,7 +3605,7 @@
             <a:r>
               <a:rPr lang="en-US" sz="2200" b="1" dirty="0">
                 <a:solidFill>
-                  <a:srgbClr val="0B1B2B"/>
+                  <a:srgbClr val="0A1622"/>
                 </a:solidFill>
                 <a:latin typeface="Consolas" pitchFamily="34" charset="0"/>
                 <a:ea typeface="Consolas" pitchFamily="34" charset="-122"/>
@@ -3468,14 +3703,36 @@
         </p:nvSpPr>
         <p:spPr>
           <a:xfrm>
+            <a:off x="1298448" y="1316736"/>
+            <a:ext cx="1005840" cy="32004"/>
+          </a:xfrm>
+          <a:prstGeom prst="rect">
+            <a:avLst/>
+          </a:prstGeom>
+          <a:solidFill>
+            <a:srgbClr val="22D3EE"/>
+          </a:solidFill>
+          <a:ln/>
+        </p:spPr>
+      </p:sp>
+      <p:sp>
+        <p:nvSpPr>
+          <p:cNvPr id="7" name="Shape 5"/>
+          <p:cNvSpPr/>
+          <p:nvPr/>
+        </p:nvSpPr>
+        <p:spPr>
+          <a:xfrm>
             <a:off x="548640" y="1691640"/>
             <a:ext cx="3886200" cy="2743200"/>
           </a:xfrm>
-          <a:prstGeom prst="rect">
-            <a:avLst/>
-          </a:prstGeom>
-          <a:solidFill>
-            <a:srgbClr val="12293D"/>
+          <a:prstGeom prst="roundRect">
+            <a:avLst>
+              <a:gd name="adj" fmla="val 1667"/>
+            </a:avLst>
+          </a:prstGeom>
+          <a:solidFill>
+            <a:srgbClr val="13283C"/>
           </a:solidFill>
           <a:ln w="15875">
             <a:solidFill>
@@ -3483,18 +3740,25 @@
             </a:solidFill>
             <a:prstDash val="solid"/>
           </a:ln>
-        </p:spPr>
-      </p:sp>
-      <p:sp>
-        <p:nvSpPr>
-          <p:cNvPr id="7" name="Shape 5"/>
-          <p:cNvSpPr/>
-          <p:nvPr/>
-        </p:nvSpPr>
-        <p:spPr>
-          <a:xfrm>
-            <a:off x="548640" y="1691640"/>
-            <a:ext cx="82296" cy="2743200"/>
+          <a:effectLst>
+            <a:outerShdw sx="100000" sy="100000" kx="0" ky="0" algn="bl" rotWithShape="0" blurRad="88900" dist="38100" dir="5400000">
+              <a:srgbClr val="000000">
+                <a:alpha val="50000"/>
+              </a:srgbClr>
+            </a:outerShdw>
+          </a:effectLst>
+        </p:spPr>
+      </p:sp>
+      <p:sp>
+        <p:nvSpPr>
+          <p:cNvPr id="8" name="Shape 6"/>
+          <p:cNvSpPr/>
+          <p:nvPr/>
+        </p:nvSpPr>
+        <p:spPr>
+          <a:xfrm>
+            <a:off x="562356" y="1764792"/>
+            <a:ext cx="73152" cy="2596896"/>
           </a:xfrm>
           <a:prstGeom prst="rect">
             <a:avLst/>
@@ -3507,14 +3771,14 @@
       </p:sp>
       <p:sp>
         <p:nvSpPr>
-          <p:cNvPr id="8" name="Text 6"/>
-          <p:cNvSpPr/>
-          <p:nvPr/>
-        </p:nvSpPr>
-        <p:spPr>
-          <a:xfrm>
-            <a:off x="786384" y="1837944"/>
-            <a:ext cx="3502152" cy="384048"/>
+          <p:cNvPr id="9" name="Text 7"/>
+          <p:cNvSpPr/>
+          <p:nvPr/>
+        </p:nvSpPr>
+        <p:spPr>
+          <a:xfrm>
+            <a:off x="804672" y="1828800"/>
+            <a:ext cx="3483864" cy="384048"/>
           </a:xfrm>
           <a:prstGeom prst="rect">
             <a:avLst/>
@@ -3530,7 +3794,7 @@
               <a:buNone/>
             </a:pPr>
             <a:r>
-              <a:rPr lang="en-US" sz="1500" b="1" dirty="0">
+              <a:rPr lang="en-US" sz="1500" b="1" spc="50" kern="0" dirty="0">
                 <a:solidFill>
                   <a:srgbClr val="FB7185"/>
                 </a:solidFill>
@@ -3546,14 +3810,34 @@
       </p:sp>
       <p:sp>
         <p:nvSpPr>
-          <p:cNvPr id="9" name="Text 7"/>
-          <p:cNvSpPr/>
-          <p:nvPr/>
-        </p:nvSpPr>
-        <p:spPr>
-          <a:xfrm>
-            <a:off x="786384" y="2276856"/>
-            <a:ext cx="3429000" cy="2011680"/>
+          <p:cNvPr id="10" name="Shape 8"/>
+          <p:cNvSpPr/>
+          <p:nvPr/>
+        </p:nvSpPr>
+        <p:spPr>
+          <a:xfrm>
+            <a:off x="804672" y="2221992"/>
+            <a:ext cx="3374136" cy="16459"/>
+          </a:xfrm>
+          <a:prstGeom prst="rect">
+            <a:avLst/>
+          </a:prstGeom>
+          <a:solidFill>
+            <a:srgbClr val="264862"/>
+          </a:solidFill>
+          <a:ln/>
+        </p:spPr>
+      </p:sp>
+      <p:sp>
+        <p:nvSpPr>
+          <p:cNvPr id="11" name="Text 9"/>
+          <p:cNvSpPr/>
+          <p:nvPr/>
+        </p:nvSpPr>
+        <p:spPr>
+          <a:xfrm>
+            <a:off x="804672" y="2331720"/>
+            <a:ext cx="3410712" cy="1956816"/>
           </a:xfrm>
           <a:prstGeom prst="rect">
             <a:avLst/>
@@ -3575,7 +3859,7 @@
             <a:r>
               <a:rPr lang="en-US" sz="1250" dirty="0">
                 <a:solidFill>
-                  <a:srgbClr val="E8EEF5"/>
+                  <a:srgbClr val="EAF1F8"/>
                 </a:solidFill>
                 <a:latin typeface="Calibri" pitchFamily="34" charset="0"/>
                 <a:ea typeface="Calibri" pitchFamily="34" charset="-122"/>
@@ -3596,7 +3880,7 @@
             <a:r>
               <a:rPr lang="en-US" sz="1250" dirty="0">
                 <a:solidFill>
-                  <a:srgbClr val="E8EEF5"/>
+                  <a:srgbClr val="EAF1F8"/>
                 </a:solidFill>
                 <a:latin typeface="Calibri" pitchFamily="34" charset="0"/>
                 <a:ea typeface="Calibri" pitchFamily="34" charset="-122"/>
@@ -3617,7 +3901,7 @@
             <a:r>
               <a:rPr lang="en-US" sz="1250" dirty="0">
                 <a:solidFill>
-                  <a:srgbClr val="E8EEF5"/>
+                  <a:srgbClr val="EAF1F8"/>
                 </a:solidFill>
                 <a:latin typeface="Calibri" pitchFamily="34" charset="0"/>
                 <a:ea typeface="Calibri" pitchFamily="34" charset="-122"/>
@@ -3638,7 +3922,7 @@
             <a:r>
               <a:rPr lang="en-US" sz="1250" dirty="0">
                 <a:solidFill>
-                  <a:srgbClr val="E8EEF5"/>
+                  <a:srgbClr val="EAF1F8"/>
                 </a:solidFill>
                 <a:latin typeface="Calibri" pitchFamily="34" charset="0"/>
                 <a:ea typeface="Calibri" pitchFamily="34" charset="-122"/>
@@ -3659,7 +3943,7 @@
             <a:r>
               <a:rPr lang="en-US" sz="1250" dirty="0">
                 <a:solidFill>
-                  <a:srgbClr val="E8EEF5"/>
+                  <a:srgbClr val="EAF1F8"/>
                 </a:solidFill>
                 <a:latin typeface="Calibri" pitchFamily="34" charset="0"/>
                 <a:ea typeface="Calibri" pitchFamily="34" charset="-122"/>
@@ -3673,7 +3957,7 @@
       </p:sp>
       <p:sp>
         <p:nvSpPr>
-          <p:cNvPr id="10" name="Shape 8"/>
+          <p:cNvPr id="12" name="Shape 10"/>
           <p:cNvSpPr/>
           <p:nvPr/>
         </p:nvSpPr>
@@ -3682,11 +3966,13 @@
             <a:off x="4663440" y="1691640"/>
             <a:ext cx="3931920" cy="2743200"/>
           </a:xfrm>
-          <a:prstGeom prst="rect">
-            <a:avLst/>
-          </a:prstGeom>
-          <a:solidFill>
-            <a:srgbClr val="12293D"/>
+          <a:prstGeom prst="roundRect">
+            <a:avLst>
+              <a:gd name="adj" fmla="val 1667"/>
+            </a:avLst>
+          </a:prstGeom>
+          <a:solidFill>
+            <a:srgbClr val="13283C"/>
           </a:solidFill>
           <a:ln w="15875">
             <a:solidFill>
@@ -3694,18 +3980,25 @@
             </a:solidFill>
             <a:prstDash val="solid"/>
           </a:ln>
-        </p:spPr>
-      </p:sp>
-      <p:sp>
-        <p:nvSpPr>
-          <p:cNvPr id="11" name="Shape 9"/>
-          <p:cNvSpPr/>
-          <p:nvPr/>
-        </p:nvSpPr>
-        <p:spPr>
-          <a:xfrm>
-            <a:off x="4663440" y="1691640"/>
-            <a:ext cx="82296" cy="2743200"/>
+          <a:effectLst>
+            <a:outerShdw sx="100000" sy="100000" kx="0" ky="0" algn="bl" rotWithShape="0" blurRad="88900" dist="38100" dir="5400000">
+              <a:srgbClr val="000000">
+                <a:alpha val="50000"/>
+              </a:srgbClr>
+            </a:outerShdw>
+          </a:effectLst>
+        </p:spPr>
+      </p:sp>
+      <p:sp>
+        <p:nvSpPr>
+          <p:cNvPr id="13" name="Shape 11"/>
+          <p:cNvSpPr/>
+          <p:nvPr/>
+        </p:nvSpPr>
+        <p:spPr>
+          <a:xfrm>
+            <a:off x="4677156" y="1764792"/>
+            <a:ext cx="73152" cy="2596896"/>
           </a:xfrm>
           <a:prstGeom prst="rect">
             <a:avLst/>
@@ -3718,14 +4011,14 @@
       </p:sp>
       <p:sp>
         <p:nvSpPr>
-          <p:cNvPr id="12" name="Text 10"/>
-          <p:cNvSpPr/>
-          <p:nvPr/>
-        </p:nvSpPr>
-        <p:spPr>
-          <a:xfrm>
-            <a:off x="4901184" y="1837944"/>
-            <a:ext cx="3547872" cy="384048"/>
+          <p:cNvPr id="14" name="Text 12"/>
+          <p:cNvSpPr/>
+          <p:nvPr/>
+        </p:nvSpPr>
+        <p:spPr>
+          <a:xfrm>
+            <a:off x="4919472" y="1828800"/>
+            <a:ext cx="3529584" cy="384048"/>
           </a:xfrm>
           <a:prstGeom prst="rect">
             <a:avLst/>
@@ -3741,7 +4034,7 @@
               <a:buNone/>
             </a:pPr>
             <a:r>
-              <a:rPr lang="en-US" sz="1500" b="1" dirty="0">
+              <a:rPr lang="en-US" sz="1500" b="1" spc="50" kern="0" dirty="0">
                 <a:solidFill>
                   <a:srgbClr val="34D399"/>
                 </a:solidFill>
@@ -3757,14 +4050,34 @@
       </p:sp>
       <p:sp>
         <p:nvSpPr>
-          <p:cNvPr id="13" name="Text 11"/>
-          <p:cNvSpPr/>
-          <p:nvPr/>
-        </p:nvSpPr>
-        <p:spPr>
-          <a:xfrm>
-            <a:off x="4901184" y="2276856"/>
-            <a:ext cx="3474720" cy="2011680"/>
+          <p:cNvPr id="15" name="Shape 13"/>
+          <p:cNvSpPr/>
+          <p:nvPr/>
+        </p:nvSpPr>
+        <p:spPr>
+          <a:xfrm>
+            <a:off x="4919472" y="2221992"/>
+            <a:ext cx="3419856" cy="16459"/>
+          </a:xfrm>
+          <a:prstGeom prst="rect">
+            <a:avLst/>
+          </a:prstGeom>
+          <a:solidFill>
+            <a:srgbClr val="264862"/>
+          </a:solidFill>
+          <a:ln/>
+        </p:spPr>
+      </p:sp>
+      <p:sp>
+        <p:nvSpPr>
+          <p:cNvPr id="16" name="Text 14"/>
+          <p:cNvSpPr/>
+          <p:nvPr/>
+        </p:nvSpPr>
+        <p:spPr>
+          <a:xfrm>
+            <a:off x="4919472" y="2331720"/>
+            <a:ext cx="3456432" cy="1956816"/>
           </a:xfrm>
           <a:prstGeom prst="rect">
             <a:avLst/>
@@ -3786,7 +4099,7 @@
             <a:r>
               <a:rPr lang="en-US" sz="1250" dirty="0">
                 <a:solidFill>
-                  <a:srgbClr val="E8EEF5"/>
+                  <a:srgbClr val="EAF1F8"/>
                 </a:solidFill>
                 <a:latin typeface="Calibri" pitchFamily="34" charset="0"/>
                 <a:ea typeface="Calibri" pitchFamily="34" charset="-122"/>
@@ -3807,7 +4120,7 @@
             <a:r>
               <a:rPr lang="en-US" sz="1250" dirty="0">
                 <a:solidFill>
-                  <a:srgbClr val="E8EEF5"/>
+                  <a:srgbClr val="EAF1F8"/>
                 </a:solidFill>
                 <a:latin typeface="Calibri" pitchFamily="34" charset="0"/>
                 <a:ea typeface="Calibri" pitchFamily="34" charset="-122"/>
@@ -3828,7 +4141,7 @@
             <a:r>
               <a:rPr lang="en-US" sz="1250" dirty="0">
                 <a:solidFill>
-                  <a:srgbClr val="E8EEF5"/>
+                  <a:srgbClr val="EAF1F8"/>
                 </a:solidFill>
                 <a:latin typeface="Calibri" pitchFamily="34" charset="0"/>
                 <a:ea typeface="Calibri" pitchFamily="34" charset="-122"/>
@@ -3849,7 +4162,7 @@
             <a:r>
               <a:rPr lang="en-US" sz="1250" dirty="0">
                 <a:solidFill>
-                  <a:srgbClr val="E8EEF5"/>
+                  <a:srgbClr val="EAF1F8"/>
                 </a:solidFill>
                 <a:latin typeface="Calibri" pitchFamily="34" charset="0"/>
                 <a:ea typeface="Calibri" pitchFamily="34" charset="-122"/>
@@ -3870,7 +4183,7 @@
             <a:r>
               <a:rPr lang="en-US" sz="1250" dirty="0">
                 <a:solidFill>
-                  <a:srgbClr val="E8EEF5"/>
+                  <a:srgbClr val="EAF1F8"/>
                 </a:solidFill>
                 <a:latin typeface="Calibri" pitchFamily="34" charset="0"/>
                 <a:ea typeface="Calibri" pitchFamily="34" charset="-122"/>
@@ -3896,7 +4209,7 @@
     <p:bg>
       <p:bgPr>
         <a:solidFill>
-          <a:srgbClr val="0B1B2B"/>
+          <a:srgbClr val="0A1622"/>
         </a:solidFill>
       </p:bgPr>
     </p:bg>
@@ -3934,6 +4247,13 @@
             <a:srgbClr val="22D3EE"/>
           </a:solidFill>
           <a:ln/>
+          <a:effectLst>
+            <a:outerShdw sx="100000" sy="100000" kx="0" ky="0" algn="bl" rotWithShape="0" blurRad="50800" dist="25400" dir="5400000">
+              <a:srgbClr val="000000">
+                <a:alpha val="40000"/>
+              </a:srgbClr>
+            </a:outerShdw>
+          </a:effectLst>
         </p:spPr>
       </p:sp>
       <p:sp>
@@ -3963,7 +4283,7 @@
             <a:r>
               <a:rPr lang="en-US" sz="2200" b="1" dirty="0">
                 <a:solidFill>
-                  <a:srgbClr val="0B1B2B"/>
+                  <a:srgbClr val="0A1622"/>
                 </a:solidFill>
                 <a:latin typeface="Consolas" pitchFamily="34" charset="0"/>
                 <a:ea typeface="Consolas" pitchFamily="34" charset="-122"/>
@@ -4055,7 +4375,27 @@
       </p:sp>
       <p:sp>
         <p:nvSpPr>
-          <p:cNvPr id="6" name="Text 4"/>
+          <p:cNvPr id="6" name="Shape 4"/>
+          <p:cNvSpPr/>
+          <p:nvPr/>
+        </p:nvSpPr>
+        <p:spPr>
+          <a:xfrm>
+            <a:off x="1298448" y="1316736"/>
+            <a:ext cx="1005840" cy="32004"/>
+          </a:xfrm>
+          <a:prstGeom prst="rect">
+            <a:avLst/>
+          </a:prstGeom>
+          <a:solidFill>
+            <a:srgbClr val="22D3EE"/>
+          </a:solidFill>
+          <a:ln/>
+        </p:spPr>
+      </p:sp>
+      <p:sp>
+        <p:nvSpPr>
+          <p:cNvPr id="7" name="Text 5"/>
           <p:cNvSpPr/>
           <p:nvPr/>
         </p:nvSpPr>
@@ -4084,7 +4424,7 @@
             <a:r>
               <a:rPr lang="en-US" sz="1600" dirty="0">
                 <a:solidFill>
-                  <a:srgbClr val="E8EEF5"/>
+                  <a:srgbClr val="EAF1F8"/>
                 </a:solidFill>
                 <a:latin typeface="Calibri" pitchFamily="34" charset="0"/>
                 <a:ea typeface="Calibri" pitchFamily="34" charset="-122"/>
@@ -4098,7 +4438,7 @@
       </p:sp>
       <p:sp>
         <p:nvSpPr>
-          <p:cNvPr id="7" name="Shape 5"/>
+          <p:cNvPr id="8" name="Shape 6"/>
           <p:cNvSpPr/>
           <p:nvPr/>
         </p:nvSpPr>
@@ -4107,30 +4447,119 @@
             <a:off x="548640" y="2286000"/>
             <a:ext cx="8046720" cy="1828800"/>
           </a:xfrm>
-          <a:prstGeom prst="rect">
-            <a:avLst/>
-          </a:prstGeom>
-          <a:solidFill>
-            <a:srgbClr val="081320"/>
+          <a:prstGeom prst="roundRect">
+            <a:avLst>
+              <a:gd name="adj" fmla="val 1750"/>
+            </a:avLst>
+          </a:prstGeom>
+          <a:solidFill>
+            <a:srgbClr val="060F1A"/>
           </a:solidFill>
           <a:ln w="12700">
             <a:solidFill>
-              <a:srgbClr val="284963"/>
+              <a:srgbClr val="264862"/>
             </a:solidFill>
             <a:prstDash val="solid"/>
           </a:ln>
-        </p:spPr>
-      </p:sp>
-      <p:sp>
-        <p:nvSpPr>
-          <p:cNvPr id="8" name="Text 6"/>
-          <p:cNvSpPr/>
-          <p:nvPr/>
-        </p:nvSpPr>
-        <p:spPr>
-          <a:xfrm>
-            <a:off x="749808" y="2414016"/>
-            <a:ext cx="7644384" cy="1572768"/>
+          <a:effectLst>
+            <a:outerShdw sx="100000" sy="100000" kx="0" ky="0" algn="bl" rotWithShape="0" blurRad="88900" dist="38100" dir="5400000">
+              <a:srgbClr val="000000">
+                <a:alpha val="50000"/>
+              </a:srgbClr>
+            </a:outerShdw>
+          </a:effectLst>
+        </p:spPr>
+      </p:sp>
+      <p:sp>
+        <p:nvSpPr>
+          <p:cNvPr id="9" name="Shape 7"/>
+          <p:cNvSpPr/>
+          <p:nvPr/>
+        </p:nvSpPr>
+        <p:spPr>
+          <a:xfrm>
+            <a:off x="566928" y="2322576"/>
+            <a:ext cx="8010144" cy="274320"/>
+          </a:xfrm>
+          <a:prstGeom prst="rect">
+            <a:avLst/>
+          </a:prstGeom>
+          <a:solidFill>
+            <a:srgbClr val="13283C"/>
+          </a:solidFill>
+          <a:ln/>
+        </p:spPr>
+      </p:sp>
+      <p:sp>
+        <p:nvSpPr>
+          <p:cNvPr id="10" name="Shape 8"/>
+          <p:cNvSpPr/>
+          <p:nvPr/>
+        </p:nvSpPr>
+        <p:spPr>
+          <a:xfrm>
+            <a:off x="713232" y="2395728"/>
+            <a:ext cx="118872" cy="118872"/>
+          </a:xfrm>
+          <a:prstGeom prst="ellipse">
+            <a:avLst/>
+          </a:prstGeom>
+          <a:solidFill>
+            <a:srgbClr val="FB7185"/>
+          </a:solidFill>
+          <a:ln/>
+        </p:spPr>
+      </p:sp>
+      <p:sp>
+        <p:nvSpPr>
+          <p:cNvPr id="11" name="Shape 9"/>
+          <p:cNvSpPr/>
+          <p:nvPr/>
+        </p:nvSpPr>
+        <p:spPr>
+          <a:xfrm>
+            <a:off x="886968" y="2395728"/>
+            <a:ext cx="118872" cy="118872"/>
+          </a:xfrm>
+          <a:prstGeom prst="ellipse">
+            <a:avLst/>
+          </a:prstGeom>
+          <a:solidFill>
+            <a:srgbClr val="FBBF24"/>
+          </a:solidFill>
+          <a:ln/>
+        </p:spPr>
+      </p:sp>
+      <p:sp>
+        <p:nvSpPr>
+          <p:cNvPr id="12" name="Shape 10"/>
+          <p:cNvSpPr/>
+          <p:nvPr/>
+        </p:nvSpPr>
+        <p:spPr>
+          <a:xfrm>
+            <a:off x="1060704" y="2395728"/>
+            <a:ext cx="118872" cy="118872"/>
+          </a:xfrm>
+          <a:prstGeom prst="ellipse">
+            <a:avLst/>
+          </a:prstGeom>
+          <a:solidFill>
+            <a:srgbClr val="34D399"/>
+          </a:solidFill>
+          <a:ln/>
+        </p:spPr>
+      </p:sp>
+      <p:sp>
+        <p:nvSpPr>
+          <p:cNvPr id="13" name="Text 11"/>
+          <p:cNvSpPr/>
+          <p:nvPr/>
+        </p:nvSpPr>
+        <p:spPr>
+          <a:xfrm>
+            <a:off x="768096" y="2706624"/>
+            <a:ext cx="7626096" cy="1280160"/>
           </a:xfrm>
           <a:prstGeom prst="rect">
             <a:avLst/>
@@ -4242,7 +4671,7 @@
     <p:bg>
       <p:bgPr>
         <a:solidFill>
-          <a:srgbClr val="0B1B2B"/>
+          <a:srgbClr val="0A1622"/>
         </a:solidFill>
       </p:bgPr>
     </p:bg>
@@ -4280,6 +4709,13 @@
             <a:srgbClr val="22D3EE"/>
           </a:solidFill>
           <a:ln/>
+          <a:effectLst>
+            <a:outerShdw sx="100000" sy="100000" kx="0" ky="0" algn="bl" rotWithShape="0" blurRad="50800" dist="25400" dir="5400000">
+              <a:srgbClr val="000000">
+                <a:alpha val="40000"/>
+              </a:srgbClr>
+            </a:outerShdw>
+          </a:effectLst>
         </p:spPr>
       </p:sp>
       <p:sp>
@@ -4309,7 +4745,7 @@
             <a:r>
               <a:rPr lang="en-US" sz="2200" b="1" dirty="0">
                 <a:solidFill>
-                  <a:srgbClr val="0B1B2B"/>
+                  <a:srgbClr val="0A1622"/>
                 </a:solidFill>
                 <a:latin typeface="Consolas" pitchFamily="34" charset="0"/>
                 <a:ea typeface="Consolas" pitchFamily="34" charset="-122"/>
@@ -4401,7 +4837,27 @@
       </p:sp>
       <p:sp>
         <p:nvSpPr>
-          <p:cNvPr id="6" name="Text 4"/>
+          <p:cNvPr id="6" name="Shape 4"/>
+          <p:cNvSpPr/>
+          <p:nvPr/>
+        </p:nvSpPr>
+        <p:spPr>
+          <a:xfrm>
+            <a:off x="1298448" y="1316736"/>
+            <a:ext cx="1005840" cy="32004"/>
+          </a:xfrm>
+          <a:prstGeom prst="rect">
+            <a:avLst/>
+          </a:prstGeom>
+          <a:solidFill>
+            <a:srgbClr val="22D3EE"/>
+          </a:solidFill>
+          <a:ln/>
+        </p:spPr>
+      </p:sp>
+      <p:sp>
+        <p:nvSpPr>
+          <p:cNvPr id="7" name="Text 5"/>
           <p:cNvSpPr/>
           <p:nvPr/>
         </p:nvSpPr>
@@ -4430,7 +4886,7 @@
             <a:r>
               <a:rPr lang="en-US" sz="1700" b="1" dirty="0">
                 <a:solidFill>
-                  <a:srgbClr val="E8EEF5"/>
+                  <a:srgbClr val="EAF1F8"/>
                 </a:solidFill>
                 <a:latin typeface="Calibri" pitchFamily="34" charset="0"/>
                 <a:ea typeface="Calibri" pitchFamily="34" charset="-122"/>
@@ -4451,7 +4907,7 @@
             <a:r>
               <a:rPr lang="en-US" sz="1700" b="1" dirty="0">
                 <a:solidFill>
-                  <a:srgbClr val="E8EEF5"/>
+                  <a:srgbClr val="EAF1F8"/>
                 </a:solidFill>
                 <a:latin typeface="Calibri" pitchFamily="34" charset="0"/>
                 <a:ea typeface="Calibri" pitchFamily="34" charset="-122"/>
@@ -4472,7 +4928,7 @@
             <a:r>
               <a:rPr lang="en-US" sz="1700" b="1" dirty="0">
                 <a:solidFill>
-                  <a:srgbClr val="E8EEF5"/>
+                  <a:srgbClr val="EAF1F8"/>
                 </a:solidFill>
                 <a:latin typeface="Calibri" pitchFamily="34" charset="0"/>
                 <a:ea typeface="Calibri" pitchFamily="34" charset="-122"/>
@@ -4493,7 +4949,7 @@
             <a:r>
               <a:rPr lang="en-US" sz="1700" b="1" dirty="0">
                 <a:solidFill>
-                  <a:srgbClr val="E8EEF5"/>
+                  <a:srgbClr val="EAF1F8"/>
                 </a:solidFill>
                 <a:latin typeface="Calibri" pitchFamily="34" charset="0"/>
                 <a:ea typeface="Calibri" pitchFamily="34" charset="-122"/>
@@ -4519,7 +4975,7 @@
     <p:bg>
       <p:bgPr>
         <a:solidFill>
-          <a:srgbClr val="0B1B2B"/>
+          <a:srgbClr val="0A1622"/>
         </a:solidFill>
       </p:bgPr>
     </p:bg>
@@ -4642,7 +5098,7 @@
             <a:r>
               <a:rPr lang="en-US" sz="1600" dirty="0">
                 <a:solidFill>
-                  <a:srgbClr val="A8B4C4"/>
+                  <a:srgbClr val="9FB0C2"/>
                 </a:solidFill>
                 <a:latin typeface="Calibri" pitchFamily="34" charset="0"/>
                 <a:ea typeface="Calibri" pitchFamily="34" charset="-122"/>
@@ -4668,7 +5124,7 @@
     <p:bg>
       <p:bgPr>
         <a:solidFill>
-          <a:srgbClr val="0B1B2B"/>
+          <a:srgbClr val="0A1622"/>
         </a:solidFill>
       </p:bgPr>
     </p:bg>
@@ -4706,6 +5162,13 @@
             <a:srgbClr val="22D3EE"/>
           </a:solidFill>
           <a:ln/>
+          <a:effectLst>
+            <a:outerShdw sx="100000" sy="100000" kx="0" ky="0" algn="bl" rotWithShape="0" blurRad="50800" dist="25400" dir="5400000">
+              <a:srgbClr val="000000">
+                <a:alpha val="40000"/>
+              </a:srgbClr>
+            </a:outerShdw>
+          </a:effectLst>
         </p:spPr>
       </p:sp>
       <p:sp>
@@ -4735,7 +5198,7 @@
             <a:r>
               <a:rPr lang="en-US" sz="2200" b="1" dirty="0">
                 <a:solidFill>
-                  <a:srgbClr val="0B1B2B"/>
+                  <a:srgbClr val="0A1622"/>
                 </a:solidFill>
                 <a:latin typeface="Consolas" pitchFamily="34" charset="0"/>
                 <a:ea typeface="Consolas" pitchFamily="34" charset="-122"/>
@@ -4833,16 +5296,36 @@
         </p:nvSpPr>
         <p:spPr>
           <a:xfrm>
+            <a:off x="1298448" y="1316736"/>
+            <a:ext cx="1005840" cy="32004"/>
+          </a:xfrm>
+          <a:prstGeom prst="rect">
+            <a:avLst/>
+          </a:prstGeom>
+          <a:solidFill>
+            <a:srgbClr val="22D3EE"/>
+          </a:solidFill>
+          <a:ln/>
+        </p:spPr>
+      </p:sp>
+      <p:sp>
+        <p:nvSpPr>
+          <p:cNvPr id="7" name="Shape 5"/>
+          <p:cNvSpPr/>
+          <p:nvPr/>
+        </p:nvSpPr>
+        <p:spPr>
+          <a:xfrm>
             <a:off x="548640" y="1828800"/>
-            <a:ext cx="1924812" cy="777240"/>
+            <a:ext cx="1911096" cy="822960"/>
           </a:xfrm>
           <a:prstGeom prst="roundRect">
             <a:avLst>
-              <a:gd name="adj" fmla="val 8235"/>
+              <a:gd name="adj" fmla="val 8889"/>
             </a:avLst>
           </a:prstGeom>
           <a:solidFill>
-            <a:srgbClr val="12293D"/>
+            <a:srgbClr val="13283C"/>
           </a:solidFill>
           <a:ln w="15875">
             <a:solidFill>
@@ -4850,18 +5333,45 @@
             </a:solidFill>
             <a:prstDash val="solid"/>
           </a:ln>
-        </p:spPr>
-      </p:sp>
-      <p:sp>
-        <p:nvSpPr>
-          <p:cNvPr id="7" name="Text 5"/>
-          <p:cNvSpPr/>
-          <p:nvPr/>
-        </p:nvSpPr>
-        <p:spPr>
-          <a:xfrm>
-            <a:off x="585216" y="1828800"/>
-            <a:ext cx="1851660" cy="777240"/>
+          <a:effectLst>
+            <a:outerShdw sx="100000" sy="100000" kx="0" ky="0" algn="bl" rotWithShape="0" blurRad="50800" dist="25400" dir="5400000">
+              <a:srgbClr val="000000">
+                <a:alpha val="40000"/>
+              </a:srgbClr>
+            </a:outerShdw>
+          </a:effectLst>
+        </p:spPr>
+      </p:sp>
+      <p:sp>
+        <p:nvSpPr>
+          <p:cNvPr id="8" name="Shape 6"/>
+          <p:cNvSpPr/>
+          <p:nvPr/>
+        </p:nvSpPr>
+        <p:spPr>
+          <a:xfrm>
+            <a:off x="658368" y="1975104"/>
+            <a:ext cx="1691640" cy="27432"/>
+          </a:xfrm>
+          <a:prstGeom prst="rect">
+            <a:avLst/>
+          </a:prstGeom>
+          <a:solidFill>
+            <a:srgbClr val="22D3EE"/>
+          </a:solidFill>
+          <a:ln/>
+        </p:spPr>
+      </p:sp>
+      <p:sp>
+        <p:nvSpPr>
+          <p:cNvPr id="9" name="Text 7"/>
+          <p:cNvSpPr/>
+          <p:nvPr/>
+        </p:nvSpPr>
+        <p:spPr>
+          <a:xfrm>
+            <a:off x="585216" y="1938528"/>
+            <a:ext cx="1837944" cy="713232"/>
           </a:xfrm>
           <a:prstGeom prst="rect">
             <a:avLst/>
@@ -4879,7 +5389,7 @@
             <a:r>
               <a:rPr lang="en-US" sz="1150" b="1" dirty="0">
                 <a:solidFill>
-                  <a:srgbClr val="E8EEF5"/>
+                  <a:srgbClr val="EAF1F8"/>
                 </a:solidFill>
                 <a:latin typeface="Calibri" pitchFamily="34" charset="0"/>
                 <a:ea typeface="Calibri" pitchFamily="34" charset="-122"/>
@@ -4893,22 +5403,61 @@
       </p:sp>
       <p:sp>
         <p:nvSpPr>
-          <p:cNvPr id="8" name="Shape 6"/>
-          <p:cNvSpPr/>
-          <p:nvPr/>
-        </p:nvSpPr>
-        <p:spPr>
-          <a:xfrm>
-            <a:off x="2619756" y="1828800"/>
-            <a:ext cx="1924812" cy="777240"/>
+          <p:cNvPr id="10" name="Text 8"/>
+          <p:cNvSpPr/>
+          <p:nvPr/>
+        </p:nvSpPr>
+        <p:spPr>
+          <a:xfrm>
+            <a:off x="2423160" y="1828800"/>
+            <a:ext cx="237744" cy="822960"/>
+          </a:xfrm>
+          <a:prstGeom prst="rect">
+            <a:avLst/>
+          </a:prstGeom>
+          <a:noFill/>
+          <a:ln/>
+        </p:spPr>
+        <p:txBody>
+          <a:bodyPr wrap="square" lIns="0" tIns="0" rIns="0" bIns="0" rtlCol="0" anchor="ctr"/>
+          <a:lstStyle/>
+          <a:p>
+            <a:pPr algn="ctr" indent="0" marL="0">
+              <a:buNone/>
+            </a:pPr>
+            <a:r>
+              <a:rPr lang="en-US" sz="1800" b="1" dirty="0">
+                <a:solidFill>
+                  <a:srgbClr val="22D3EE"/>
+                </a:solidFill>
+                <a:latin typeface="Trebuchet MS" pitchFamily="34" charset="0"/>
+                <a:ea typeface="Trebuchet MS" pitchFamily="34" charset="-122"/>
+                <a:cs typeface="Trebuchet MS" pitchFamily="34" charset="-120"/>
+              </a:rPr>
+              <a:t>›</a:t>
+            </a:r>
+            <a:endParaRPr lang="en-US" sz="1800" dirty="0"/>
+          </a:p>
+        </p:txBody>
+      </p:sp>
+      <p:sp>
+        <p:nvSpPr>
+          <p:cNvPr id="11" name="Shape 9"/>
+          <p:cNvSpPr/>
+          <p:nvPr/>
+        </p:nvSpPr>
+        <p:spPr>
+          <a:xfrm>
+            <a:off x="2624328" y="1828800"/>
+            <a:ext cx="1911096" cy="822960"/>
           </a:xfrm>
           <a:prstGeom prst="roundRect">
             <a:avLst>
-              <a:gd name="adj" fmla="val 8235"/>
+              <a:gd name="adj" fmla="val 8889"/>
             </a:avLst>
           </a:prstGeom>
           <a:solidFill>
-            <a:srgbClr val="12293D"/>
+            <a:srgbClr val="13283C"/>
           </a:solidFill>
           <a:ln w="15875">
             <a:solidFill>
@@ -4916,18 +5465,45 @@
             </a:solidFill>
             <a:prstDash val="solid"/>
           </a:ln>
-        </p:spPr>
-      </p:sp>
-      <p:sp>
-        <p:nvSpPr>
-          <p:cNvPr id="9" name="Text 7"/>
-          <p:cNvSpPr/>
-          <p:nvPr/>
-        </p:nvSpPr>
-        <p:spPr>
-          <a:xfrm>
-            <a:off x="2656332" y="1828800"/>
-            <a:ext cx="1851660" cy="777240"/>
+          <a:effectLst>
+            <a:outerShdw sx="100000" sy="100000" kx="0" ky="0" algn="bl" rotWithShape="0" blurRad="50800" dist="25400" dir="5400000">
+              <a:srgbClr val="000000">
+                <a:alpha val="40000"/>
+              </a:srgbClr>
+            </a:outerShdw>
+          </a:effectLst>
+        </p:spPr>
+      </p:sp>
+      <p:sp>
+        <p:nvSpPr>
+          <p:cNvPr id="12" name="Shape 10"/>
+          <p:cNvSpPr/>
+          <p:nvPr/>
+        </p:nvSpPr>
+        <p:spPr>
+          <a:xfrm>
+            <a:off x="2734056" y="1975104"/>
+            <a:ext cx="1691640" cy="27432"/>
+          </a:xfrm>
+          <a:prstGeom prst="rect">
+            <a:avLst/>
+          </a:prstGeom>
+          <a:solidFill>
+            <a:srgbClr val="22D3EE"/>
+          </a:solidFill>
+          <a:ln/>
+        </p:spPr>
+      </p:sp>
+      <p:sp>
+        <p:nvSpPr>
+          <p:cNvPr id="13" name="Text 11"/>
+          <p:cNvSpPr/>
+          <p:nvPr/>
+        </p:nvSpPr>
+        <p:spPr>
+          <a:xfrm>
+            <a:off x="2660904" y="1938528"/>
+            <a:ext cx="1837944" cy="713232"/>
           </a:xfrm>
           <a:prstGeom prst="rect">
             <a:avLst/>
@@ -4945,7 +5521,7 @@
             <a:r>
               <a:rPr lang="en-US" sz="1150" b="1" dirty="0">
                 <a:solidFill>
-                  <a:srgbClr val="E8EEF5"/>
+                  <a:srgbClr val="EAF1F8"/>
                 </a:solidFill>
                 <a:latin typeface="Calibri" pitchFamily="34" charset="0"/>
                 <a:ea typeface="Calibri" pitchFamily="34" charset="-122"/>
@@ -4962,7 +5538,7 @@
             <a:r>
               <a:rPr lang="en-US" sz="1150" b="1" dirty="0">
                 <a:solidFill>
-                  <a:srgbClr val="E8EEF5"/>
+                  <a:srgbClr val="EAF1F8"/>
                 </a:solidFill>
                 <a:latin typeface="Calibri" pitchFamily="34" charset="0"/>
                 <a:ea typeface="Calibri" pitchFamily="34" charset="-122"/>
@@ -4976,22 +5552,61 @@
       </p:sp>
       <p:sp>
         <p:nvSpPr>
-          <p:cNvPr id="10" name="Shape 8"/>
-          <p:cNvSpPr/>
-          <p:nvPr/>
-        </p:nvSpPr>
-        <p:spPr>
-          <a:xfrm>
-            <a:off x="4690872" y="1828800"/>
-            <a:ext cx="1924812" cy="777240"/>
+          <p:cNvPr id="14" name="Text 12"/>
+          <p:cNvSpPr/>
+          <p:nvPr/>
+        </p:nvSpPr>
+        <p:spPr>
+          <a:xfrm>
+            <a:off x="4498848" y="1828800"/>
+            <a:ext cx="237744" cy="822960"/>
+          </a:xfrm>
+          <a:prstGeom prst="rect">
+            <a:avLst/>
+          </a:prstGeom>
+          <a:noFill/>
+          <a:ln/>
+        </p:spPr>
+        <p:txBody>
+          <a:bodyPr wrap="square" lIns="0" tIns="0" rIns="0" bIns="0" rtlCol="0" anchor="ctr"/>
+          <a:lstStyle/>
+          <a:p>
+            <a:pPr algn="ctr" indent="0" marL="0">
+              <a:buNone/>
+            </a:pPr>
+            <a:r>
+              <a:rPr lang="en-US" sz="1800" b="1" dirty="0">
+                <a:solidFill>
+                  <a:srgbClr val="22D3EE"/>
+                </a:solidFill>
+                <a:latin typeface="Trebuchet MS" pitchFamily="34" charset="0"/>
+                <a:ea typeface="Trebuchet MS" pitchFamily="34" charset="-122"/>
+                <a:cs typeface="Trebuchet MS" pitchFamily="34" charset="-120"/>
+              </a:rPr>
+              <a:t>›</a:t>
+            </a:r>
+            <a:endParaRPr lang="en-US" sz="1800" dirty="0"/>
+          </a:p>
+        </p:txBody>
+      </p:sp>
+      <p:sp>
+        <p:nvSpPr>
+          <p:cNvPr id="15" name="Shape 13"/>
+          <p:cNvSpPr/>
+          <p:nvPr/>
+        </p:nvSpPr>
+        <p:spPr>
+          <a:xfrm>
+            <a:off x="4700016" y="1828800"/>
+            <a:ext cx="1911096" cy="822960"/>
           </a:xfrm>
           <a:prstGeom prst="roundRect">
             <a:avLst>
-              <a:gd name="adj" fmla="val 8235"/>
+              <a:gd name="adj" fmla="val 8889"/>
             </a:avLst>
           </a:prstGeom>
           <a:solidFill>
-            <a:srgbClr val="12293D"/>
+            <a:srgbClr val="13283C"/>
           </a:solidFill>
           <a:ln w="15875">
             <a:solidFill>
@@ -4999,18 +5614,45 @@
             </a:solidFill>
             <a:prstDash val="solid"/>
           </a:ln>
-        </p:spPr>
-      </p:sp>
-      <p:sp>
-        <p:nvSpPr>
-          <p:cNvPr id="11" name="Text 9"/>
-          <p:cNvSpPr/>
-          <p:nvPr/>
-        </p:nvSpPr>
-        <p:spPr>
-          <a:xfrm>
-            <a:off x="4727448" y="1828800"/>
-            <a:ext cx="1851660" cy="777240"/>
+          <a:effectLst>
+            <a:outerShdw sx="100000" sy="100000" kx="0" ky="0" algn="bl" rotWithShape="0" blurRad="50800" dist="25400" dir="5400000">
+              <a:srgbClr val="000000">
+                <a:alpha val="40000"/>
+              </a:srgbClr>
+            </a:outerShdw>
+          </a:effectLst>
+        </p:spPr>
+      </p:sp>
+      <p:sp>
+        <p:nvSpPr>
+          <p:cNvPr id="16" name="Shape 14"/>
+          <p:cNvSpPr/>
+          <p:nvPr/>
+        </p:nvSpPr>
+        <p:spPr>
+          <a:xfrm>
+            <a:off x="4809744" y="1975104"/>
+            <a:ext cx="1691640" cy="27432"/>
+          </a:xfrm>
+          <a:prstGeom prst="rect">
+            <a:avLst/>
+          </a:prstGeom>
+          <a:solidFill>
+            <a:srgbClr val="22D3EE"/>
+          </a:solidFill>
+          <a:ln/>
+        </p:spPr>
+      </p:sp>
+      <p:sp>
+        <p:nvSpPr>
+          <p:cNvPr id="17" name="Text 15"/>
+          <p:cNvSpPr/>
+          <p:nvPr/>
+        </p:nvSpPr>
+        <p:spPr>
+          <a:xfrm>
+            <a:off x="4736592" y="1938528"/>
+            <a:ext cx="1837944" cy="713232"/>
           </a:xfrm>
           <a:prstGeom prst="rect">
             <a:avLst/>
@@ -5028,7 +5670,7 @@
             <a:r>
               <a:rPr lang="en-US" sz="1150" b="1" dirty="0">
                 <a:solidFill>
-                  <a:srgbClr val="E8EEF5"/>
+                  <a:srgbClr val="EAF1F8"/>
                 </a:solidFill>
                 <a:latin typeface="Calibri" pitchFamily="34" charset="0"/>
                 <a:ea typeface="Calibri" pitchFamily="34" charset="-122"/>
@@ -5045,7 +5687,7 @@
             <a:r>
               <a:rPr lang="en-US" sz="1150" b="1" dirty="0">
                 <a:solidFill>
-                  <a:srgbClr val="E8EEF5"/>
+                  <a:srgbClr val="EAF1F8"/>
                 </a:solidFill>
                 <a:latin typeface="Calibri" pitchFamily="34" charset="0"/>
                 <a:ea typeface="Calibri" pitchFamily="34" charset="-122"/>
@@ -5059,22 +5701,61 @@
       </p:sp>
       <p:sp>
         <p:nvSpPr>
-          <p:cNvPr id="12" name="Shape 10"/>
-          <p:cNvSpPr/>
-          <p:nvPr/>
-        </p:nvSpPr>
-        <p:spPr>
-          <a:xfrm>
-            <a:off x="6761988" y="1828800"/>
-            <a:ext cx="1924812" cy="777240"/>
+          <p:cNvPr id="18" name="Text 16"/>
+          <p:cNvSpPr/>
+          <p:nvPr/>
+        </p:nvSpPr>
+        <p:spPr>
+          <a:xfrm>
+            <a:off x="6574536" y="1828800"/>
+            <a:ext cx="237744" cy="822960"/>
+          </a:xfrm>
+          <a:prstGeom prst="rect">
+            <a:avLst/>
+          </a:prstGeom>
+          <a:noFill/>
+          <a:ln/>
+        </p:spPr>
+        <p:txBody>
+          <a:bodyPr wrap="square" lIns="0" tIns="0" rIns="0" bIns="0" rtlCol="0" anchor="ctr"/>
+          <a:lstStyle/>
+          <a:p>
+            <a:pPr algn="ctr" indent="0" marL="0">
+              <a:buNone/>
+            </a:pPr>
+            <a:r>
+              <a:rPr lang="en-US" sz="1800" b="1" dirty="0">
+                <a:solidFill>
+                  <a:srgbClr val="22D3EE"/>
+                </a:solidFill>
+                <a:latin typeface="Trebuchet MS" pitchFamily="34" charset="0"/>
+                <a:ea typeface="Trebuchet MS" pitchFamily="34" charset="-122"/>
+                <a:cs typeface="Trebuchet MS" pitchFamily="34" charset="-120"/>
+              </a:rPr>
+              <a:t>›</a:t>
+            </a:r>
+            <a:endParaRPr lang="en-US" sz="1800" dirty="0"/>
+          </a:p>
+        </p:txBody>
+      </p:sp>
+      <p:sp>
+        <p:nvSpPr>
+          <p:cNvPr id="19" name="Shape 17"/>
+          <p:cNvSpPr/>
+          <p:nvPr/>
+        </p:nvSpPr>
+        <p:spPr>
+          <a:xfrm>
+            <a:off x="6775704" y="1828800"/>
+            <a:ext cx="1911096" cy="822960"/>
           </a:xfrm>
           <a:prstGeom prst="roundRect">
             <a:avLst>
-              <a:gd name="adj" fmla="val 8235"/>
+              <a:gd name="adj" fmla="val 8889"/>
             </a:avLst>
           </a:prstGeom>
           <a:solidFill>
-            <a:srgbClr val="12293D"/>
+            <a:srgbClr val="13283C"/>
           </a:solidFill>
           <a:ln w="15875">
             <a:solidFill>
@@ -5082,18 +5763,45 @@
             </a:solidFill>
             <a:prstDash val="solid"/>
           </a:ln>
-        </p:spPr>
-      </p:sp>
-      <p:sp>
-        <p:nvSpPr>
-          <p:cNvPr id="13" name="Text 11"/>
-          <p:cNvSpPr/>
-          <p:nvPr/>
-        </p:nvSpPr>
-        <p:spPr>
-          <a:xfrm>
-            <a:off x="6798564" y="1828800"/>
-            <a:ext cx="1851660" cy="777240"/>
+          <a:effectLst>
+            <a:outerShdw sx="100000" sy="100000" kx="0" ky="0" algn="bl" rotWithShape="0" blurRad="50800" dist="25400" dir="5400000">
+              <a:srgbClr val="000000">
+                <a:alpha val="40000"/>
+              </a:srgbClr>
+            </a:outerShdw>
+          </a:effectLst>
+        </p:spPr>
+      </p:sp>
+      <p:sp>
+        <p:nvSpPr>
+          <p:cNvPr id="20" name="Shape 18"/>
+          <p:cNvSpPr/>
+          <p:nvPr/>
+        </p:nvSpPr>
+        <p:spPr>
+          <a:xfrm>
+            <a:off x="6885432" y="1975104"/>
+            <a:ext cx="1691640" cy="27432"/>
+          </a:xfrm>
+          <a:prstGeom prst="rect">
+            <a:avLst/>
+          </a:prstGeom>
+          <a:solidFill>
+            <a:srgbClr val="22D3EE"/>
+          </a:solidFill>
+          <a:ln/>
+        </p:spPr>
+      </p:sp>
+      <p:sp>
+        <p:nvSpPr>
+          <p:cNvPr id="21" name="Text 19"/>
+          <p:cNvSpPr/>
+          <p:nvPr/>
+        </p:nvSpPr>
+        <p:spPr>
+          <a:xfrm>
+            <a:off x="6812280" y="1938528"/>
+            <a:ext cx="1837944" cy="713232"/>
           </a:xfrm>
           <a:prstGeom prst="rect">
             <a:avLst/>
@@ -5111,7 +5819,7 @@
             <a:r>
               <a:rPr lang="en-US" sz="1150" b="1" dirty="0">
                 <a:solidFill>
-                  <a:srgbClr val="E8EEF5"/>
+                  <a:srgbClr val="EAF1F8"/>
                 </a:solidFill>
                 <a:latin typeface="Calibri" pitchFamily="34" charset="0"/>
                 <a:ea typeface="Calibri" pitchFamily="34" charset="-122"/>
@@ -5128,7 +5836,7 @@
             <a:r>
               <a:rPr lang="en-US" sz="1150" b="1" dirty="0">
                 <a:solidFill>
-                  <a:srgbClr val="E8EEF5"/>
+                  <a:srgbClr val="EAF1F8"/>
                 </a:solidFill>
                 <a:latin typeface="Calibri" pitchFamily="34" charset="0"/>
                 <a:ea typeface="Calibri" pitchFamily="34" charset="-122"/>
@@ -5142,7 +5850,7 @@
       </p:sp>
       <p:sp>
         <p:nvSpPr>
-          <p:cNvPr id="14" name="Text 12"/>
+          <p:cNvPr id="22" name="Text 20"/>
           <p:cNvSpPr/>
           <p:nvPr/>
         </p:nvSpPr>
@@ -5171,7 +5879,7 @@
             <a:r>
               <a:rPr lang="en-US" sz="1500" b="1" dirty="0">
                 <a:solidFill>
-                  <a:srgbClr val="E8EEF5"/>
+                  <a:srgbClr val="EAF1F8"/>
                 </a:solidFill>
                 <a:latin typeface="Calibri" pitchFamily="34" charset="0"/>
                 <a:ea typeface="Calibri" pitchFamily="34" charset="-122"/>
@@ -5192,7 +5900,7 @@
             <a:r>
               <a:rPr lang="en-US" sz="1500" dirty="0">
                 <a:solidFill>
-                  <a:srgbClr val="E8EEF5"/>
+                  <a:srgbClr val="EAF1F8"/>
                 </a:solidFill>
                 <a:latin typeface="Calibri" pitchFamily="34" charset="0"/>
                 <a:ea typeface="Calibri" pitchFamily="34" charset="-122"/>
@@ -5213,7 +5921,7 @@
             <a:r>
               <a:rPr lang="en-US" sz="1500" dirty="0">
                 <a:solidFill>
-                  <a:srgbClr val="E8EEF5"/>
+                  <a:srgbClr val="EAF1F8"/>
                 </a:solidFill>
                 <a:latin typeface="Calibri" pitchFamily="34" charset="0"/>
                 <a:ea typeface="Calibri" pitchFamily="34" charset="-122"/>
@@ -5234,7 +5942,7 @@
             <a:r>
               <a:rPr lang="en-US" sz="1500" dirty="0">
                 <a:solidFill>
-                  <a:srgbClr val="E8EEF5"/>
+                  <a:srgbClr val="EAF1F8"/>
                 </a:solidFill>
                 <a:latin typeface="Calibri" pitchFamily="34" charset="0"/>
                 <a:ea typeface="Calibri" pitchFamily="34" charset="-122"/>
@@ -5260,7 +5968,7 @@
     <p:bg>
       <p:bgPr>
         <a:solidFill>
-          <a:srgbClr val="0B1B2B"/>
+          <a:srgbClr val="0A1622"/>
         </a:solidFill>
       </p:bgPr>
     </p:bg>
@@ -5298,6 +6006,13 @@
             <a:srgbClr val="22D3EE"/>
           </a:solidFill>
           <a:ln/>
+          <a:effectLst>
+            <a:outerShdw sx="100000" sy="100000" kx="0" ky="0" algn="bl" rotWithShape="0" blurRad="50800" dist="25400" dir="5400000">
+              <a:srgbClr val="000000">
+                <a:alpha val="40000"/>
+              </a:srgbClr>
+            </a:outerShdw>
+          </a:effectLst>
         </p:spPr>
       </p:sp>
       <p:sp>
@@ -5327,7 +6042,7 @@
             <a:r>
               <a:rPr lang="en-US" sz="2200" b="1" dirty="0">
                 <a:solidFill>
-                  <a:srgbClr val="0B1B2B"/>
+                  <a:srgbClr val="0A1622"/>
                 </a:solidFill>
                 <a:latin typeface="Consolas" pitchFamily="34" charset="0"/>
                 <a:ea typeface="Consolas" pitchFamily="34" charset="-122"/>
@@ -5425,14 +6140,36 @@
         </p:nvSpPr>
         <p:spPr>
           <a:xfrm>
+            <a:off x="1298448" y="1316736"/>
+            <a:ext cx="1005840" cy="32004"/>
+          </a:xfrm>
+          <a:prstGeom prst="rect">
+            <a:avLst/>
+          </a:prstGeom>
+          <a:solidFill>
+            <a:srgbClr val="22D3EE"/>
+          </a:solidFill>
+          <a:ln/>
+        </p:spPr>
+      </p:sp>
+      <p:sp>
+        <p:nvSpPr>
+          <p:cNvPr id="7" name="Shape 5"/>
+          <p:cNvSpPr/>
+          <p:nvPr/>
+        </p:nvSpPr>
+        <p:spPr>
+          <a:xfrm>
             <a:off x="548640" y="1920240"/>
             <a:ext cx="8046720" cy="1554480"/>
           </a:xfrm>
-          <a:prstGeom prst="rect">
-            <a:avLst/>
-          </a:prstGeom>
-          <a:solidFill>
-            <a:srgbClr val="12293D"/>
+          <a:prstGeom prst="roundRect">
+            <a:avLst>
+              <a:gd name="adj" fmla="val 2941"/>
+            </a:avLst>
+          </a:prstGeom>
+          <a:solidFill>
+            <a:srgbClr val="13283C"/>
           </a:solidFill>
           <a:ln w="19050">
             <a:solidFill>
@@ -5440,18 +6177,25 @@
             </a:solidFill>
             <a:prstDash val="solid"/>
           </a:ln>
-        </p:spPr>
-      </p:sp>
-      <p:sp>
-        <p:nvSpPr>
-          <p:cNvPr id="7" name="Shape 5"/>
-          <p:cNvSpPr/>
-          <p:nvPr/>
-        </p:nvSpPr>
-        <p:spPr>
-          <a:xfrm>
-            <a:off x="548640" y="1920240"/>
-            <a:ext cx="91440" cy="1554480"/>
+          <a:effectLst>
+            <a:outerShdw sx="100000" sy="100000" kx="0" ky="0" algn="bl" rotWithShape="0" blurRad="88900" dist="38100" dir="5400000">
+              <a:srgbClr val="000000">
+                <a:alpha val="50000"/>
+              </a:srgbClr>
+            </a:outerShdw>
+          </a:effectLst>
+        </p:spPr>
+      </p:sp>
+      <p:sp>
+        <p:nvSpPr>
+          <p:cNvPr id="8" name="Shape 6"/>
+          <p:cNvSpPr/>
+          <p:nvPr/>
+        </p:nvSpPr>
+        <p:spPr>
+          <a:xfrm>
+            <a:off x="562356" y="1993392"/>
+            <a:ext cx="91440" cy="1408176"/>
           </a:xfrm>
           <a:prstGeom prst="rect">
             <a:avLst/>
@@ -5464,13 +6208,13 @@
       </p:sp>
       <p:sp>
         <p:nvSpPr>
-          <p:cNvPr id="8" name="Text 6"/>
-          <p:cNvSpPr/>
-          <p:nvPr/>
-        </p:nvSpPr>
-        <p:spPr>
-          <a:xfrm>
-            <a:off x="868680" y="2121408"/>
+          <p:cNvPr id="9" name="Text 7"/>
+          <p:cNvSpPr/>
+          <p:nvPr/>
+        </p:nvSpPr>
+        <p:spPr>
+          <a:xfrm>
+            <a:off x="896112" y="2121408"/>
             <a:ext cx="7498080" cy="777240"/>
           </a:xfrm>
           <a:prstGeom prst="rect">
@@ -5503,13 +6247,13 @@
       </p:sp>
       <p:sp>
         <p:nvSpPr>
-          <p:cNvPr id="9" name="Text 7"/>
-          <p:cNvSpPr/>
-          <p:nvPr/>
-        </p:nvSpPr>
-        <p:spPr>
-          <a:xfrm>
-            <a:off x="868680" y="2834640"/>
+          <p:cNvPr id="10" name="Text 8"/>
+          <p:cNvSpPr/>
+          <p:nvPr/>
+        </p:nvSpPr>
+        <p:spPr>
+          <a:xfrm>
+            <a:off x="896112" y="2834640"/>
             <a:ext cx="7498080" cy="548640"/>
           </a:xfrm>
           <a:prstGeom prst="rect">
@@ -5528,7 +6272,7 @@
             <a:r>
               <a:rPr lang="en-US" sz="1500" dirty="0">
                 <a:solidFill>
-                  <a:srgbClr val="E8EEF5"/>
+                  <a:srgbClr val="EAF1F8"/>
                 </a:solidFill>
                 <a:latin typeface="Calibri" pitchFamily="34" charset="0"/>
                 <a:ea typeface="Calibri" pitchFamily="34" charset="-122"/>
@@ -5542,7 +6286,7 @@
       </p:sp>
       <p:sp>
         <p:nvSpPr>
-          <p:cNvPr id="10" name="Text 8"/>
+          <p:cNvPr id="11" name="Text 9"/>
           <p:cNvSpPr/>
           <p:nvPr/>
         </p:nvSpPr>
@@ -5571,7 +6315,7 @@
             <a:r>
               <a:rPr lang="en-US" sz="1500" dirty="0">
                 <a:solidFill>
-                  <a:srgbClr val="E8EEF5"/>
+                  <a:srgbClr val="EAF1F8"/>
                 </a:solidFill>
                 <a:latin typeface="Calibri" pitchFamily="34" charset="0"/>
                 <a:ea typeface="Calibri" pitchFamily="34" charset="-122"/>
@@ -5597,7 +6341,7 @@
     <p:bg>
       <p:bgPr>
         <a:solidFill>
-          <a:srgbClr val="0B1B2B"/>
+          <a:srgbClr val="0A1622"/>
         </a:solidFill>
       </p:bgPr>
     </p:bg>
@@ -5635,6 +6379,13 @@
             <a:srgbClr val="22D3EE"/>
           </a:solidFill>
           <a:ln/>
+          <a:effectLst>
+            <a:outerShdw sx="100000" sy="100000" kx="0" ky="0" algn="bl" rotWithShape="0" blurRad="50800" dist="25400" dir="5400000">
+              <a:srgbClr val="000000">
+                <a:alpha val="40000"/>
+              </a:srgbClr>
+            </a:outerShdw>
+          </a:effectLst>
         </p:spPr>
       </p:sp>
       <p:sp>
@@ -5664,7 +6415,7 @@
             <a:r>
               <a:rPr lang="en-US" sz="2200" b="1" dirty="0">
                 <a:solidFill>
-                  <a:srgbClr val="0B1B2B"/>
+                  <a:srgbClr val="0A1622"/>
                 </a:solidFill>
                 <a:latin typeface="Consolas" pitchFamily="34" charset="0"/>
                 <a:ea typeface="Consolas" pitchFamily="34" charset="-122"/>
@@ -5756,7 +6507,27 @@
       </p:sp>
       <p:sp>
         <p:nvSpPr>
-          <p:cNvPr id="6" name="Text 4"/>
+          <p:cNvPr id="6" name="Shape 4"/>
+          <p:cNvSpPr/>
+          <p:nvPr/>
+        </p:nvSpPr>
+        <p:spPr>
+          <a:xfrm>
+            <a:off x="1298448" y="1316736"/>
+            <a:ext cx="1005840" cy="32004"/>
+          </a:xfrm>
+          <a:prstGeom prst="rect">
+            <a:avLst/>
+          </a:prstGeom>
+          <a:solidFill>
+            <a:srgbClr val="22D3EE"/>
+          </a:solidFill>
+          <a:ln/>
+        </p:spPr>
+      </p:sp>
+      <p:sp>
+        <p:nvSpPr>
+          <p:cNvPr id="7" name="Text 5"/>
           <p:cNvSpPr/>
           <p:nvPr/>
         </p:nvSpPr>
@@ -5785,7 +6556,7 @@
             <a:r>
               <a:rPr lang="en-US" sz="1600" b="1" dirty="0">
                 <a:solidFill>
-                  <a:srgbClr val="E8EEF5"/>
+                  <a:srgbClr val="EAF1F8"/>
                 </a:solidFill>
                 <a:latin typeface="Calibri" pitchFamily="34" charset="0"/>
                 <a:ea typeface="Calibri" pitchFamily="34" charset="-122"/>
@@ -5806,7 +6577,7 @@
             <a:r>
               <a:rPr lang="en-US" sz="1600" dirty="0">
                 <a:solidFill>
-                  <a:srgbClr val="E8EEF5"/>
+                  <a:srgbClr val="EAF1F8"/>
                 </a:solidFill>
                 <a:latin typeface="Calibri" pitchFamily="34" charset="0"/>
                 <a:ea typeface="Calibri" pitchFamily="34" charset="-122"/>
@@ -5827,7 +6598,7 @@
             <a:r>
               <a:rPr lang="en-US" sz="1600" dirty="0">
                 <a:solidFill>
-                  <a:srgbClr val="E8EEF5"/>
+                  <a:srgbClr val="EAF1F8"/>
                 </a:solidFill>
                 <a:latin typeface="Calibri" pitchFamily="34" charset="0"/>
                 <a:ea typeface="Calibri" pitchFamily="34" charset="-122"/>
@@ -5848,7 +6619,7 @@
             <a:r>
               <a:rPr lang="en-US" sz="1600" dirty="0">
                 <a:solidFill>
-                  <a:srgbClr val="E8EEF5"/>
+                  <a:srgbClr val="EAF1F8"/>
                 </a:solidFill>
                 <a:latin typeface="Calibri" pitchFamily="34" charset="0"/>
                 <a:ea typeface="Calibri" pitchFamily="34" charset="-122"/>
@@ -5874,7 +6645,7 @@
     <p:bg>
       <p:bgPr>
         <a:solidFill>
-          <a:srgbClr val="0B1B2B"/>
+          <a:srgbClr val="0A1622"/>
         </a:solidFill>
       </p:bgPr>
     </p:bg>
@@ -5912,6 +6683,13 @@
             <a:srgbClr val="22D3EE"/>
           </a:solidFill>
           <a:ln/>
+          <a:effectLst>
+            <a:outerShdw sx="100000" sy="100000" kx="0" ky="0" algn="bl" rotWithShape="0" blurRad="50800" dist="25400" dir="5400000">
+              <a:srgbClr val="000000">
+                <a:alpha val="40000"/>
+              </a:srgbClr>
+            </a:outerShdw>
+          </a:effectLst>
         </p:spPr>
       </p:sp>
       <p:sp>
@@ -5941,7 +6719,7 @@
             <a:r>
               <a:rPr lang="en-US" sz="2200" b="1" dirty="0">
                 <a:solidFill>
-                  <a:srgbClr val="0B1B2B"/>
+                  <a:srgbClr val="0A1622"/>
                 </a:solidFill>
                 <a:latin typeface="Consolas" pitchFamily="34" charset="0"/>
                 <a:ea typeface="Consolas" pitchFamily="34" charset="-122"/>
@@ -6039,16 +6817,36 @@
         </p:nvSpPr>
         <p:spPr>
           <a:xfrm>
+            <a:off x="1298448" y="1316736"/>
+            <a:ext cx="1005840" cy="32004"/>
+          </a:xfrm>
+          <a:prstGeom prst="rect">
+            <a:avLst/>
+          </a:prstGeom>
+          <a:solidFill>
+            <a:srgbClr val="22D3EE"/>
+          </a:solidFill>
+          <a:ln/>
+        </p:spPr>
+      </p:sp>
+      <p:sp>
+        <p:nvSpPr>
+          <p:cNvPr id="7" name="Shape 5"/>
+          <p:cNvSpPr/>
+          <p:nvPr/>
+        </p:nvSpPr>
+        <p:spPr>
+          <a:xfrm>
             <a:off x="548640" y="1920240"/>
-            <a:ext cx="1037191" cy="777240"/>
+            <a:ext cx="1021515" cy="822960"/>
           </a:xfrm>
           <a:prstGeom prst="roundRect">
             <a:avLst>
-              <a:gd name="adj" fmla="val 8235"/>
+              <a:gd name="adj" fmla="val 8889"/>
             </a:avLst>
           </a:prstGeom>
           <a:solidFill>
-            <a:srgbClr val="12293D"/>
+            <a:srgbClr val="13283C"/>
           </a:solidFill>
           <a:ln w="15875">
             <a:solidFill>
@@ -6056,18 +6854,45 @@
             </a:solidFill>
             <a:prstDash val="solid"/>
           </a:ln>
-        </p:spPr>
-      </p:sp>
-      <p:sp>
-        <p:nvSpPr>
-          <p:cNvPr id="7" name="Text 5"/>
-          <p:cNvSpPr/>
-          <p:nvPr/>
-        </p:nvSpPr>
-        <p:spPr>
-          <a:xfrm>
-            <a:off x="585216" y="1920240"/>
-            <a:ext cx="964039" cy="777240"/>
+          <a:effectLst>
+            <a:outerShdw sx="100000" sy="100000" kx="0" ky="0" algn="bl" rotWithShape="0" blurRad="50800" dist="25400" dir="5400000">
+              <a:srgbClr val="000000">
+                <a:alpha val="40000"/>
+              </a:srgbClr>
+            </a:outerShdw>
+          </a:effectLst>
+        </p:spPr>
+      </p:sp>
+      <p:sp>
+        <p:nvSpPr>
+          <p:cNvPr id="8" name="Shape 6"/>
+          <p:cNvSpPr/>
+          <p:nvPr/>
+        </p:nvSpPr>
+        <p:spPr>
+          <a:xfrm>
+            <a:off x="658368" y="2066544"/>
+            <a:ext cx="802059" cy="27432"/>
+          </a:xfrm>
+          <a:prstGeom prst="rect">
+            <a:avLst/>
+          </a:prstGeom>
+          <a:solidFill>
+            <a:srgbClr val="22D3EE"/>
+          </a:solidFill>
+          <a:ln/>
+        </p:spPr>
+      </p:sp>
+      <p:sp>
+        <p:nvSpPr>
+          <p:cNvPr id="9" name="Text 7"/>
+          <p:cNvSpPr/>
+          <p:nvPr/>
+        </p:nvSpPr>
+        <p:spPr>
+          <a:xfrm>
+            <a:off x="585216" y="2029968"/>
+            <a:ext cx="948363" cy="713232"/>
           </a:xfrm>
           <a:prstGeom prst="rect">
             <a:avLst/>
@@ -6085,7 +6910,7 @@
             <a:r>
               <a:rPr lang="en-US" sz="1150" b="1" dirty="0">
                 <a:solidFill>
-                  <a:srgbClr val="E8EEF5"/>
+                  <a:srgbClr val="EAF1F8"/>
                 </a:solidFill>
                 <a:latin typeface="Calibri" pitchFamily="34" charset="0"/>
                 <a:ea typeface="Calibri" pitchFamily="34" charset="-122"/>
@@ -6099,22 +6924,61 @@
       </p:sp>
       <p:sp>
         <p:nvSpPr>
-          <p:cNvPr id="8" name="Shape 6"/>
-          <p:cNvSpPr/>
-          <p:nvPr/>
-        </p:nvSpPr>
-        <p:spPr>
-          <a:xfrm>
-            <a:off x="1732135" y="1920240"/>
-            <a:ext cx="1037191" cy="777240"/>
+          <p:cNvPr id="10" name="Text 8"/>
+          <p:cNvSpPr/>
+          <p:nvPr/>
+        </p:nvSpPr>
+        <p:spPr>
+          <a:xfrm>
+            <a:off x="1533579" y="1920240"/>
+            <a:ext cx="237744" cy="822960"/>
+          </a:xfrm>
+          <a:prstGeom prst="rect">
+            <a:avLst/>
+          </a:prstGeom>
+          <a:noFill/>
+          <a:ln/>
+        </p:spPr>
+        <p:txBody>
+          <a:bodyPr wrap="square" lIns="0" tIns="0" rIns="0" bIns="0" rtlCol="0" anchor="ctr"/>
+          <a:lstStyle/>
+          <a:p>
+            <a:pPr algn="ctr" indent="0" marL="0">
+              <a:buNone/>
+            </a:pPr>
+            <a:r>
+              <a:rPr lang="en-US" sz="1800" b="1" dirty="0">
+                <a:solidFill>
+                  <a:srgbClr val="22D3EE"/>
+                </a:solidFill>
+                <a:latin typeface="Trebuchet MS" pitchFamily="34" charset="0"/>
+                <a:ea typeface="Trebuchet MS" pitchFamily="34" charset="-122"/>
+                <a:cs typeface="Trebuchet MS" pitchFamily="34" charset="-120"/>
+              </a:rPr>
+              <a:t>›</a:t>
+            </a:r>
+            <a:endParaRPr lang="en-US" sz="1800" dirty="0"/>
+          </a:p>
+        </p:txBody>
+      </p:sp>
+      <p:sp>
+        <p:nvSpPr>
+          <p:cNvPr id="11" name="Shape 9"/>
+          <p:cNvSpPr/>
+          <p:nvPr/>
+        </p:nvSpPr>
+        <p:spPr>
+          <a:xfrm>
+            <a:off x="1734747" y="1920240"/>
+            <a:ext cx="1021515" cy="822960"/>
           </a:xfrm>
           <a:prstGeom prst="roundRect">
             <a:avLst>
-              <a:gd name="adj" fmla="val 8235"/>
+              <a:gd name="adj" fmla="val 8889"/>
             </a:avLst>
           </a:prstGeom>
           <a:solidFill>
-            <a:srgbClr val="12293D"/>
+            <a:srgbClr val="13283C"/>
           </a:solidFill>
           <a:ln w="15875">
             <a:solidFill>
@@ -6122,18 +6986,45 @@
             </a:solidFill>
             <a:prstDash val="solid"/>
           </a:ln>
-        </p:spPr>
-      </p:sp>
-      <p:sp>
-        <p:nvSpPr>
-          <p:cNvPr id="9" name="Text 7"/>
-          <p:cNvSpPr/>
-          <p:nvPr/>
-        </p:nvSpPr>
-        <p:spPr>
-          <a:xfrm>
-            <a:off x="1768711" y="1920240"/>
-            <a:ext cx="964039" cy="777240"/>
+          <a:effectLst>
+            <a:outerShdw sx="100000" sy="100000" kx="0" ky="0" algn="bl" rotWithShape="0" blurRad="50800" dist="25400" dir="5400000">
+              <a:srgbClr val="000000">
+                <a:alpha val="40000"/>
+              </a:srgbClr>
+            </a:outerShdw>
+          </a:effectLst>
+        </p:spPr>
+      </p:sp>
+      <p:sp>
+        <p:nvSpPr>
+          <p:cNvPr id="12" name="Shape 10"/>
+          <p:cNvSpPr/>
+          <p:nvPr/>
+        </p:nvSpPr>
+        <p:spPr>
+          <a:xfrm>
+            <a:off x="1844475" y="2066544"/>
+            <a:ext cx="802059" cy="27432"/>
+          </a:xfrm>
+          <a:prstGeom prst="rect">
+            <a:avLst/>
+          </a:prstGeom>
+          <a:solidFill>
+            <a:srgbClr val="22D3EE"/>
+          </a:solidFill>
+          <a:ln/>
+        </p:spPr>
+      </p:sp>
+      <p:sp>
+        <p:nvSpPr>
+          <p:cNvPr id="13" name="Text 11"/>
+          <p:cNvSpPr/>
+          <p:nvPr/>
+        </p:nvSpPr>
+        <p:spPr>
+          <a:xfrm>
+            <a:off x="1771323" y="2029968"/>
+            <a:ext cx="948363" cy="713232"/>
           </a:xfrm>
           <a:prstGeom prst="rect">
             <a:avLst/>
@@ -6151,7 +7042,7 @@
             <a:r>
               <a:rPr lang="en-US" sz="1150" b="1" dirty="0">
                 <a:solidFill>
-                  <a:srgbClr val="E8EEF5"/>
+                  <a:srgbClr val="EAF1F8"/>
                 </a:solidFill>
                 <a:latin typeface="Calibri" pitchFamily="34" charset="0"/>
                 <a:ea typeface="Calibri" pitchFamily="34" charset="-122"/>
@@ -6165,22 +7056,61 @@
       </p:sp>
       <p:sp>
         <p:nvSpPr>
-          <p:cNvPr id="10" name="Shape 8"/>
-          <p:cNvSpPr/>
-          <p:nvPr/>
-        </p:nvSpPr>
-        <p:spPr>
-          <a:xfrm>
-            <a:off x="2915630" y="1920240"/>
-            <a:ext cx="1037191" cy="777240"/>
+          <p:cNvPr id="14" name="Text 12"/>
+          <p:cNvSpPr/>
+          <p:nvPr/>
+        </p:nvSpPr>
+        <p:spPr>
+          <a:xfrm>
+            <a:off x="2719687" y="1920240"/>
+            <a:ext cx="237744" cy="822960"/>
+          </a:xfrm>
+          <a:prstGeom prst="rect">
+            <a:avLst/>
+          </a:prstGeom>
+          <a:noFill/>
+          <a:ln/>
+        </p:spPr>
+        <p:txBody>
+          <a:bodyPr wrap="square" lIns="0" tIns="0" rIns="0" bIns="0" rtlCol="0" anchor="ctr"/>
+          <a:lstStyle/>
+          <a:p>
+            <a:pPr algn="ctr" indent="0" marL="0">
+              <a:buNone/>
+            </a:pPr>
+            <a:r>
+              <a:rPr lang="en-US" sz="1800" b="1" dirty="0">
+                <a:solidFill>
+                  <a:srgbClr val="22D3EE"/>
+                </a:solidFill>
+                <a:latin typeface="Trebuchet MS" pitchFamily="34" charset="0"/>
+                <a:ea typeface="Trebuchet MS" pitchFamily="34" charset="-122"/>
+                <a:cs typeface="Trebuchet MS" pitchFamily="34" charset="-120"/>
+              </a:rPr>
+              <a:t>›</a:t>
+            </a:r>
+            <a:endParaRPr lang="en-US" sz="1800" dirty="0"/>
+          </a:p>
+        </p:txBody>
+      </p:sp>
+      <p:sp>
+        <p:nvSpPr>
+          <p:cNvPr id="15" name="Shape 13"/>
+          <p:cNvSpPr/>
+          <p:nvPr/>
+        </p:nvSpPr>
+        <p:spPr>
+          <a:xfrm>
+            <a:off x="2920855" y="1920240"/>
+            <a:ext cx="1021515" cy="822960"/>
           </a:xfrm>
           <a:prstGeom prst="roundRect">
             <a:avLst>
-              <a:gd name="adj" fmla="val 8235"/>
+              <a:gd name="adj" fmla="val 8889"/>
             </a:avLst>
           </a:prstGeom>
           <a:solidFill>
-            <a:srgbClr val="12293D"/>
+            <a:srgbClr val="13283C"/>
           </a:solidFill>
           <a:ln w="15875">
             <a:solidFill>
@@ -6188,18 +7118,45 @@
             </a:solidFill>
             <a:prstDash val="solid"/>
           </a:ln>
-        </p:spPr>
-      </p:sp>
-      <p:sp>
-        <p:nvSpPr>
-          <p:cNvPr id="11" name="Text 9"/>
-          <p:cNvSpPr/>
-          <p:nvPr/>
-        </p:nvSpPr>
-        <p:spPr>
-          <a:xfrm>
-            <a:off x="2952206" y="1920240"/>
-            <a:ext cx="964039" cy="777240"/>
+          <a:effectLst>
+            <a:outerShdw sx="100000" sy="100000" kx="0" ky="0" algn="bl" rotWithShape="0" blurRad="50800" dist="25400" dir="5400000">
+              <a:srgbClr val="000000">
+                <a:alpha val="40000"/>
+              </a:srgbClr>
+            </a:outerShdw>
+          </a:effectLst>
+        </p:spPr>
+      </p:sp>
+      <p:sp>
+        <p:nvSpPr>
+          <p:cNvPr id="16" name="Shape 14"/>
+          <p:cNvSpPr/>
+          <p:nvPr/>
+        </p:nvSpPr>
+        <p:spPr>
+          <a:xfrm>
+            <a:off x="3030583" y="2066544"/>
+            <a:ext cx="802059" cy="27432"/>
+          </a:xfrm>
+          <a:prstGeom prst="rect">
+            <a:avLst/>
+          </a:prstGeom>
+          <a:solidFill>
+            <a:srgbClr val="22D3EE"/>
+          </a:solidFill>
+          <a:ln/>
+        </p:spPr>
+      </p:sp>
+      <p:sp>
+        <p:nvSpPr>
+          <p:cNvPr id="17" name="Text 15"/>
+          <p:cNvSpPr/>
+          <p:nvPr/>
+        </p:nvSpPr>
+        <p:spPr>
+          <a:xfrm>
+            <a:off x="2957431" y="2029968"/>
+            <a:ext cx="948363" cy="713232"/>
           </a:xfrm>
           <a:prstGeom prst="rect">
             <a:avLst/>
@@ -6217,7 +7174,7 @@
             <a:r>
               <a:rPr lang="en-US" sz="1150" b="1" dirty="0">
                 <a:solidFill>
-                  <a:srgbClr val="E8EEF5"/>
+                  <a:srgbClr val="EAF1F8"/>
                 </a:solidFill>
                 <a:latin typeface="Calibri" pitchFamily="34" charset="0"/>
                 <a:ea typeface="Calibri" pitchFamily="34" charset="-122"/>
@@ -6231,22 +7188,61 @@
       </p:sp>
       <p:sp>
         <p:nvSpPr>
-          <p:cNvPr id="12" name="Shape 10"/>
-          <p:cNvSpPr/>
-          <p:nvPr/>
-        </p:nvSpPr>
-        <p:spPr>
-          <a:xfrm>
-            <a:off x="4099125" y="1920240"/>
-            <a:ext cx="1037191" cy="777240"/>
+          <p:cNvPr id="18" name="Text 16"/>
+          <p:cNvSpPr/>
+          <p:nvPr/>
+        </p:nvSpPr>
+        <p:spPr>
+          <a:xfrm>
+            <a:off x="3905794" y="1920240"/>
+            <a:ext cx="237744" cy="822960"/>
+          </a:xfrm>
+          <a:prstGeom prst="rect">
+            <a:avLst/>
+          </a:prstGeom>
+          <a:noFill/>
+          <a:ln/>
+        </p:spPr>
+        <p:txBody>
+          <a:bodyPr wrap="square" lIns="0" tIns="0" rIns="0" bIns="0" rtlCol="0" anchor="ctr"/>
+          <a:lstStyle/>
+          <a:p>
+            <a:pPr algn="ctr" indent="0" marL="0">
+              <a:buNone/>
+            </a:pPr>
+            <a:r>
+              <a:rPr lang="en-US" sz="1800" b="1" dirty="0">
+                <a:solidFill>
+                  <a:srgbClr val="22D3EE"/>
+                </a:solidFill>
+                <a:latin typeface="Trebuchet MS" pitchFamily="34" charset="0"/>
+                <a:ea typeface="Trebuchet MS" pitchFamily="34" charset="-122"/>
+                <a:cs typeface="Trebuchet MS" pitchFamily="34" charset="-120"/>
+              </a:rPr>
+              <a:t>›</a:t>
+            </a:r>
+            <a:endParaRPr lang="en-US" sz="1800" dirty="0"/>
+          </a:p>
+        </p:txBody>
+      </p:sp>
+      <p:sp>
+        <p:nvSpPr>
+          <p:cNvPr id="19" name="Shape 17"/>
+          <p:cNvSpPr/>
+          <p:nvPr/>
+        </p:nvSpPr>
+        <p:spPr>
+          <a:xfrm>
+            <a:off x="4106962" y="1920240"/>
+            <a:ext cx="1021515" cy="822960"/>
           </a:xfrm>
           <a:prstGeom prst="roundRect">
             <a:avLst>
-              <a:gd name="adj" fmla="val 8235"/>
+              <a:gd name="adj" fmla="val 8889"/>
             </a:avLst>
           </a:prstGeom>
           <a:solidFill>
-            <a:srgbClr val="12293D"/>
+            <a:srgbClr val="13283C"/>
           </a:solidFill>
           <a:ln w="15875">
             <a:solidFill>
@@ -6254,18 +7250,45 @@
             </a:solidFill>
             <a:prstDash val="solid"/>
           </a:ln>
-        </p:spPr>
-      </p:sp>
-      <p:sp>
-        <p:nvSpPr>
-          <p:cNvPr id="13" name="Text 11"/>
-          <p:cNvSpPr/>
-          <p:nvPr/>
-        </p:nvSpPr>
-        <p:spPr>
-          <a:xfrm>
-            <a:off x="4135701" y="1920240"/>
-            <a:ext cx="964039" cy="777240"/>
+          <a:effectLst>
+            <a:outerShdw sx="100000" sy="100000" kx="0" ky="0" algn="bl" rotWithShape="0" blurRad="50800" dist="25400" dir="5400000">
+              <a:srgbClr val="000000">
+                <a:alpha val="40000"/>
+              </a:srgbClr>
+            </a:outerShdw>
+          </a:effectLst>
+        </p:spPr>
+      </p:sp>
+      <p:sp>
+        <p:nvSpPr>
+          <p:cNvPr id="20" name="Shape 18"/>
+          <p:cNvSpPr/>
+          <p:nvPr/>
+        </p:nvSpPr>
+        <p:spPr>
+          <a:xfrm>
+            <a:off x="4216690" y="2066544"/>
+            <a:ext cx="802059" cy="27432"/>
+          </a:xfrm>
+          <a:prstGeom prst="rect">
+            <a:avLst/>
+          </a:prstGeom>
+          <a:solidFill>
+            <a:srgbClr val="22D3EE"/>
+          </a:solidFill>
+          <a:ln/>
+        </p:spPr>
+      </p:sp>
+      <p:sp>
+        <p:nvSpPr>
+          <p:cNvPr id="21" name="Text 19"/>
+          <p:cNvSpPr/>
+          <p:nvPr/>
+        </p:nvSpPr>
+        <p:spPr>
+          <a:xfrm>
+            <a:off x="4143538" y="2029968"/>
+            <a:ext cx="948363" cy="713232"/>
           </a:xfrm>
           <a:prstGeom prst="rect">
             <a:avLst/>
@@ -6283,7 +7306,7 @@
             <a:r>
               <a:rPr lang="en-US" sz="1150" b="1" dirty="0">
                 <a:solidFill>
-                  <a:srgbClr val="E8EEF5"/>
+                  <a:srgbClr val="EAF1F8"/>
                 </a:solidFill>
                 <a:latin typeface="Calibri" pitchFamily="34" charset="0"/>
                 <a:ea typeface="Calibri" pitchFamily="34" charset="-122"/>
@@ -6297,22 +7320,61 @@
       </p:sp>
       <p:sp>
         <p:nvSpPr>
-          <p:cNvPr id="14" name="Shape 12"/>
-          <p:cNvSpPr/>
-          <p:nvPr/>
-        </p:nvSpPr>
-        <p:spPr>
-          <a:xfrm>
-            <a:off x="5282619" y="1920240"/>
-            <a:ext cx="1037191" cy="777240"/>
+          <p:cNvPr id="22" name="Text 20"/>
+          <p:cNvSpPr/>
+          <p:nvPr/>
+        </p:nvSpPr>
+        <p:spPr>
+          <a:xfrm>
+            <a:off x="5091902" y="1920240"/>
+            <a:ext cx="237744" cy="822960"/>
+          </a:xfrm>
+          <a:prstGeom prst="rect">
+            <a:avLst/>
+          </a:prstGeom>
+          <a:noFill/>
+          <a:ln/>
+        </p:spPr>
+        <p:txBody>
+          <a:bodyPr wrap="square" lIns="0" tIns="0" rIns="0" bIns="0" rtlCol="0" anchor="ctr"/>
+          <a:lstStyle/>
+          <a:p>
+            <a:pPr algn="ctr" indent="0" marL="0">
+              <a:buNone/>
+            </a:pPr>
+            <a:r>
+              <a:rPr lang="en-US" sz="1800" b="1" dirty="0">
+                <a:solidFill>
+                  <a:srgbClr val="22D3EE"/>
+                </a:solidFill>
+                <a:latin typeface="Trebuchet MS" pitchFamily="34" charset="0"/>
+                <a:ea typeface="Trebuchet MS" pitchFamily="34" charset="-122"/>
+                <a:cs typeface="Trebuchet MS" pitchFamily="34" charset="-120"/>
+              </a:rPr>
+              <a:t>›</a:t>
+            </a:r>
+            <a:endParaRPr lang="en-US" sz="1800" dirty="0"/>
+          </a:p>
+        </p:txBody>
+      </p:sp>
+      <p:sp>
+        <p:nvSpPr>
+          <p:cNvPr id="23" name="Shape 21"/>
+          <p:cNvSpPr/>
+          <p:nvPr/>
+        </p:nvSpPr>
+        <p:spPr>
+          <a:xfrm>
+            <a:off x="5293070" y="1920240"/>
+            <a:ext cx="1021515" cy="822960"/>
           </a:xfrm>
           <a:prstGeom prst="roundRect">
             <a:avLst>
-              <a:gd name="adj" fmla="val 8235"/>
+              <a:gd name="adj" fmla="val 8889"/>
             </a:avLst>
           </a:prstGeom>
           <a:solidFill>
-            <a:srgbClr val="12293D"/>
+            <a:srgbClr val="13283C"/>
           </a:solidFill>
           <a:ln w="15875">
             <a:solidFill>
@@ -6320,18 +7382,45 @@
             </a:solidFill>
             <a:prstDash val="solid"/>
           </a:ln>
-        </p:spPr>
-      </p:sp>
-      <p:sp>
-        <p:nvSpPr>
-          <p:cNvPr id="15" name="Text 13"/>
-          <p:cNvSpPr/>
-          <p:nvPr/>
-        </p:nvSpPr>
-        <p:spPr>
-          <a:xfrm>
-            <a:off x="5319195" y="1920240"/>
-            <a:ext cx="964039" cy="777240"/>
+          <a:effectLst>
+            <a:outerShdw sx="100000" sy="100000" kx="0" ky="0" algn="bl" rotWithShape="0" blurRad="50800" dist="25400" dir="5400000">
+              <a:srgbClr val="000000">
+                <a:alpha val="40000"/>
+              </a:srgbClr>
+            </a:outerShdw>
+          </a:effectLst>
+        </p:spPr>
+      </p:sp>
+      <p:sp>
+        <p:nvSpPr>
+          <p:cNvPr id="24" name="Shape 22"/>
+          <p:cNvSpPr/>
+          <p:nvPr/>
+        </p:nvSpPr>
+        <p:spPr>
+          <a:xfrm>
+            <a:off x="5402798" y="2066544"/>
+            <a:ext cx="802059" cy="27432"/>
+          </a:xfrm>
+          <a:prstGeom prst="rect">
+            <a:avLst/>
+          </a:prstGeom>
+          <a:solidFill>
+            <a:srgbClr val="22D3EE"/>
+          </a:solidFill>
+          <a:ln/>
+        </p:spPr>
+      </p:sp>
+      <p:sp>
+        <p:nvSpPr>
+          <p:cNvPr id="25" name="Text 23"/>
+          <p:cNvSpPr/>
+          <p:nvPr/>
+        </p:nvSpPr>
+        <p:spPr>
+          <a:xfrm>
+            <a:off x="5329646" y="2029968"/>
+            <a:ext cx="948363" cy="713232"/>
           </a:xfrm>
           <a:prstGeom prst="rect">
             <a:avLst/>
@@ -6349,7 +7438,7 @@
             <a:r>
               <a:rPr lang="en-US" sz="1150" b="1" dirty="0">
                 <a:solidFill>
-                  <a:srgbClr val="E8EEF5"/>
+                  <a:srgbClr val="EAF1F8"/>
                 </a:solidFill>
                 <a:latin typeface="Calibri" pitchFamily="34" charset="0"/>
                 <a:ea typeface="Calibri" pitchFamily="34" charset="-122"/>
@@ -6363,22 +7452,61 @@
       </p:sp>
       <p:sp>
         <p:nvSpPr>
-          <p:cNvPr id="16" name="Shape 14"/>
-          <p:cNvSpPr/>
-          <p:nvPr/>
-        </p:nvSpPr>
-        <p:spPr>
-          <a:xfrm>
-            <a:off x="6466114" y="1920240"/>
-            <a:ext cx="1037191" cy="777240"/>
+          <p:cNvPr id="26" name="Text 24"/>
+          <p:cNvSpPr/>
+          <p:nvPr/>
+        </p:nvSpPr>
+        <p:spPr>
+          <a:xfrm>
+            <a:off x="6278009" y="1920240"/>
+            <a:ext cx="237744" cy="822960"/>
+          </a:xfrm>
+          <a:prstGeom prst="rect">
+            <a:avLst/>
+          </a:prstGeom>
+          <a:noFill/>
+          <a:ln/>
+        </p:spPr>
+        <p:txBody>
+          <a:bodyPr wrap="square" lIns="0" tIns="0" rIns="0" bIns="0" rtlCol="0" anchor="ctr"/>
+          <a:lstStyle/>
+          <a:p>
+            <a:pPr algn="ctr" indent="0" marL="0">
+              <a:buNone/>
+            </a:pPr>
+            <a:r>
+              <a:rPr lang="en-US" sz="1800" b="1" dirty="0">
+                <a:solidFill>
+                  <a:srgbClr val="22D3EE"/>
+                </a:solidFill>
+                <a:latin typeface="Trebuchet MS" pitchFamily="34" charset="0"/>
+                <a:ea typeface="Trebuchet MS" pitchFamily="34" charset="-122"/>
+                <a:cs typeface="Trebuchet MS" pitchFamily="34" charset="-120"/>
+              </a:rPr>
+              <a:t>›</a:t>
+            </a:r>
+            <a:endParaRPr lang="en-US" sz="1800" dirty="0"/>
+          </a:p>
+        </p:txBody>
+      </p:sp>
+      <p:sp>
+        <p:nvSpPr>
+          <p:cNvPr id="27" name="Shape 25"/>
+          <p:cNvSpPr/>
+          <p:nvPr/>
+        </p:nvSpPr>
+        <p:spPr>
+          <a:xfrm>
+            <a:off x="6479177" y="1920240"/>
+            <a:ext cx="1021515" cy="822960"/>
           </a:xfrm>
           <a:prstGeom prst="roundRect">
             <a:avLst>
-              <a:gd name="adj" fmla="val 8235"/>
+              <a:gd name="adj" fmla="val 8889"/>
             </a:avLst>
           </a:prstGeom>
           <a:solidFill>
-            <a:srgbClr val="12293D"/>
+            <a:srgbClr val="13283C"/>
           </a:solidFill>
           <a:ln w="15875">
             <a:solidFill>
@@ -6386,18 +7514,45 @@
             </a:solidFill>
             <a:prstDash val="solid"/>
           </a:ln>
-        </p:spPr>
-      </p:sp>
-      <p:sp>
-        <p:nvSpPr>
-          <p:cNvPr id="17" name="Text 15"/>
-          <p:cNvSpPr/>
-          <p:nvPr/>
-        </p:nvSpPr>
-        <p:spPr>
-          <a:xfrm>
-            <a:off x="6502690" y="1920240"/>
-            <a:ext cx="964039" cy="777240"/>
+          <a:effectLst>
+            <a:outerShdw sx="100000" sy="100000" kx="0" ky="0" algn="bl" rotWithShape="0" blurRad="50800" dist="25400" dir="5400000">
+              <a:srgbClr val="000000">
+                <a:alpha val="40000"/>
+              </a:srgbClr>
+            </a:outerShdw>
+          </a:effectLst>
+        </p:spPr>
+      </p:sp>
+      <p:sp>
+        <p:nvSpPr>
+          <p:cNvPr id="28" name="Shape 26"/>
+          <p:cNvSpPr/>
+          <p:nvPr/>
+        </p:nvSpPr>
+        <p:spPr>
+          <a:xfrm>
+            <a:off x="6588905" y="2066544"/>
+            <a:ext cx="802059" cy="27432"/>
+          </a:xfrm>
+          <a:prstGeom prst="rect">
+            <a:avLst/>
+          </a:prstGeom>
+          <a:solidFill>
+            <a:srgbClr val="22D3EE"/>
+          </a:solidFill>
+          <a:ln/>
+        </p:spPr>
+      </p:sp>
+      <p:sp>
+        <p:nvSpPr>
+          <p:cNvPr id="29" name="Text 27"/>
+          <p:cNvSpPr/>
+          <p:nvPr/>
+        </p:nvSpPr>
+        <p:spPr>
+          <a:xfrm>
+            <a:off x="6515753" y="2029968"/>
+            <a:ext cx="948363" cy="713232"/>
           </a:xfrm>
           <a:prstGeom prst="rect">
             <a:avLst/>
@@ -6415,7 +7570,7 @@
             <a:r>
               <a:rPr lang="en-US" sz="1150" b="1" dirty="0">
                 <a:solidFill>
-                  <a:srgbClr val="E8EEF5"/>
+                  <a:srgbClr val="EAF1F8"/>
                 </a:solidFill>
                 <a:latin typeface="Calibri" pitchFamily="34" charset="0"/>
                 <a:ea typeface="Calibri" pitchFamily="34" charset="-122"/>
@@ -6429,22 +7584,61 @@
       </p:sp>
       <p:sp>
         <p:nvSpPr>
-          <p:cNvPr id="18" name="Shape 16"/>
-          <p:cNvSpPr/>
-          <p:nvPr/>
-        </p:nvSpPr>
-        <p:spPr>
-          <a:xfrm>
-            <a:off x="7649609" y="1920240"/>
-            <a:ext cx="1037191" cy="777240"/>
+          <p:cNvPr id="30" name="Text 28"/>
+          <p:cNvSpPr/>
+          <p:nvPr/>
+        </p:nvSpPr>
+        <p:spPr>
+          <a:xfrm>
+            <a:off x="7464117" y="1920240"/>
+            <a:ext cx="237744" cy="822960"/>
+          </a:xfrm>
+          <a:prstGeom prst="rect">
+            <a:avLst/>
+          </a:prstGeom>
+          <a:noFill/>
+          <a:ln/>
+        </p:spPr>
+        <p:txBody>
+          <a:bodyPr wrap="square" lIns="0" tIns="0" rIns="0" bIns="0" rtlCol="0" anchor="ctr"/>
+          <a:lstStyle/>
+          <a:p>
+            <a:pPr algn="ctr" indent="0" marL="0">
+              <a:buNone/>
+            </a:pPr>
+            <a:r>
+              <a:rPr lang="en-US" sz="1800" b="1" dirty="0">
+                <a:solidFill>
+                  <a:srgbClr val="22D3EE"/>
+                </a:solidFill>
+                <a:latin typeface="Trebuchet MS" pitchFamily="34" charset="0"/>
+                <a:ea typeface="Trebuchet MS" pitchFamily="34" charset="-122"/>
+                <a:cs typeface="Trebuchet MS" pitchFamily="34" charset="-120"/>
+              </a:rPr>
+              <a:t>›</a:t>
+            </a:r>
+            <a:endParaRPr lang="en-US" sz="1800" dirty="0"/>
+          </a:p>
+        </p:txBody>
+      </p:sp>
+      <p:sp>
+        <p:nvSpPr>
+          <p:cNvPr id="31" name="Shape 29"/>
+          <p:cNvSpPr/>
+          <p:nvPr/>
+        </p:nvSpPr>
+        <p:spPr>
+          <a:xfrm>
+            <a:off x="7665285" y="1920240"/>
+            <a:ext cx="1021515" cy="822960"/>
           </a:xfrm>
           <a:prstGeom prst="roundRect">
             <a:avLst>
-              <a:gd name="adj" fmla="val 8235"/>
+              <a:gd name="adj" fmla="val 8889"/>
             </a:avLst>
           </a:prstGeom>
           <a:solidFill>
-            <a:srgbClr val="12293D"/>
+            <a:srgbClr val="13283C"/>
           </a:solidFill>
           <a:ln w="15875">
             <a:solidFill>
@@ -6452,18 +7646,45 @@
             </a:solidFill>
             <a:prstDash val="solid"/>
           </a:ln>
-        </p:spPr>
-      </p:sp>
-      <p:sp>
-        <p:nvSpPr>
-          <p:cNvPr id="19" name="Text 17"/>
-          <p:cNvSpPr/>
-          <p:nvPr/>
-        </p:nvSpPr>
-        <p:spPr>
-          <a:xfrm>
-            <a:off x="7686185" y="1920240"/>
-            <a:ext cx="964039" cy="777240"/>
+          <a:effectLst>
+            <a:outerShdw sx="100000" sy="100000" kx="0" ky="0" algn="bl" rotWithShape="0" blurRad="50800" dist="25400" dir="5400000">
+              <a:srgbClr val="000000">
+                <a:alpha val="40000"/>
+              </a:srgbClr>
+            </a:outerShdw>
+          </a:effectLst>
+        </p:spPr>
+      </p:sp>
+      <p:sp>
+        <p:nvSpPr>
+          <p:cNvPr id="32" name="Shape 30"/>
+          <p:cNvSpPr/>
+          <p:nvPr/>
+        </p:nvSpPr>
+        <p:spPr>
+          <a:xfrm>
+            <a:off x="7775013" y="2066544"/>
+            <a:ext cx="802059" cy="27432"/>
+          </a:xfrm>
+          <a:prstGeom prst="rect">
+            <a:avLst/>
+          </a:prstGeom>
+          <a:solidFill>
+            <a:srgbClr val="22D3EE"/>
+          </a:solidFill>
+          <a:ln/>
+        </p:spPr>
+      </p:sp>
+      <p:sp>
+        <p:nvSpPr>
+          <p:cNvPr id="33" name="Text 31"/>
+          <p:cNvSpPr/>
+          <p:nvPr/>
+        </p:nvSpPr>
+        <p:spPr>
+          <a:xfrm>
+            <a:off x="7701861" y="2029968"/>
+            <a:ext cx="948363" cy="713232"/>
           </a:xfrm>
           <a:prstGeom prst="rect">
             <a:avLst/>
@@ -6481,7 +7702,7 @@
             <a:r>
               <a:rPr lang="en-US" sz="1150" b="1" dirty="0">
                 <a:solidFill>
-                  <a:srgbClr val="E8EEF5"/>
+                  <a:srgbClr val="EAF1F8"/>
                 </a:solidFill>
                 <a:latin typeface="Calibri" pitchFamily="34" charset="0"/>
                 <a:ea typeface="Calibri" pitchFamily="34" charset="-122"/>
@@ -6495,7 +7716,7 @@
       </p:sp>
       <p:sp>
         <p:nvSpPr>
-          <p:cNvPr id="20" name="Text 18"/>
+          <p:cNvPr id="34" name="Text 32"/>
           <p:cNvSpPr/>
           <p:nvPr/>
         </p:nvSpPr>
@@ -6524,7 +7745,7 @@
             <a:r>
               <a:rPr lang="en-US" sz="1600" dirty="0">
                 <a:solidFill>
-                  <a:srgbClr val="E8EEF5"/>
+                  <a:srgbClr val="EAF1F8"/>
                 </a:solidFill>
                 <a:latin typeface="Calibri" pitchFamily="34" charset="0"/>
                 <a:ea typeface="Calibri" pitchFamily="34" charset="-122"/>
@@ -6545,7 +7766,7 @@
             <a:r>
               <a:rPr lang="en-US" sz="1600" dirty="0">
                 <a:solidFill>
-                  <a:srgbClr val="E8EEF5"/>
+                  <a:srgbClr val="EAF1F8"/>
                 </a:solidFill>
                 <a:latin typeface="Calibri" pitchFamily="34" charset="0"/>
                 <a:ea typeface="Calibri" pitchFamily="34" charset="-122"/>
@@ -6571,7 +7792,7 @@
     <p:bg>
       <p:bgPr>
         <a:solidFill>
-          <a:srgbClr val="0B1B2B"/>
+          <a:srgbClr val="0A1622"/>
         </a:solidFill>
       </p:bgPr>
     </p:bg>
@@ -6609,6 +7830,13 @@
             <a:srgbClr val="22D3EE"/>
           </a:solidFill>
           <a:ln/>
+          <a:effectLst>
+            <a:outerShdw sx="100000" sy="100000" kx="0" ky="0" algn="bl" rotWithShape="0" blurRad="50800" dist="25400" dir="5400000">
+              <a:srgbClr val="000000">
+                <a:alpha val="40000"/>
+              </a:srgbClr>
+            </a:outerShdw>
+          </a:effectLst>
         </p:spPr>
       </p:sp>
       <p:sp>
@@ -6638,7 +7866,7 @@
             <a:r>
               <a:rPr lang="en-US" sz="2200" b="1" dirty="0">
                 <a:solidFill>
-                  <a:srgbClr val="0B1B2B"/>
+                  <a:srgbClr val="0A1622"/>
                 </a:solidFill>
                 <a:latin typeface="Consolas" pitchFamily="34" charset="0"/>
                 <a:ea typeface="Consolas" pitchFamily="34" charset="-122"/>
@@ -6736,14 +7964,36 @@
         </p:nvSpPr>
         <p:spPr>
           <a:xfrm>
+            <a:off x="1298448" y="1316736"/>
+            <a:ext cx="1005840" cy="32004"/>
+          </a:xfrm>
+          <a:prstGeom prst="rect">
+            <a:avLst/>
+          </a:prstGeom>
+          <a:solidFill>
+            <a:srgbClr val="22D3EE"/>
+          </a:solidFill>
+          <a:ln/>
+        </p:spPr>
+      </p:sp>
+      <p:sp>
+        <p:nvSpPr>
+          <p:cNvPr id="7" name="Shape 5"/>
+          <p:cNvSpPr/>
+          <p:nvPr/>
+        </p:nvSpPr>
+        <p:spPr>
+          <a:xfrm>
             <a:off x="548640" y="1691640"/>
             <a:ext cx="2542032" cy="2834640"/>
           </a:xfrm>
-          <a:prstGeom prst="rect">
-            <a:avLst/>
-          </a:prstGeom>
-          <a:solidFill>
-            <a:srgbClr val="12293D"/>
+          <a:prstGeom prst="roundRect">
+            <a:avLst>
+              <a:gd name="adj" fmla="val 1799"/>
+            </a:avLst>
+          </a:prstGeom>
+          <a:solidFill>
+            <a:srgbClr val="13283C"/>
           </a:solidFill>
           <a:ln w="15875">
             <a:solidFill>
@@ -6751,18 +8001,25 @@
             </a:solidFill>
             <a:prstDash val="solid"/>
           </a:ln>
-        </p:spPr>
-      </p:sp>
-      <p:sp>
-        <p:nvSpPr>
-          <p:cNvPr id="7" name="Shape 5"/>
-          <p:cNvSpPr/>
-          <p:nvPr/>
-        </p:nvSpPr>
-        <p:spPr>
-          <a:xfrm>
-            <a:off x="548640" y="1691640"/>
-            <a:ext cx="82296" cy="2834640"/>
+          <a:effectLst>
+            <a:outerShdw sx="100000" sy="100000" kx="0" ky="0" algn="bl" rotWithShape="0" blurRad="88900" dist="38100" dir="5400000">
+              <a:srgbClr val="000000">
+                <a:alpha val="50000"/>
+              </a:srgbClr>
+            </a:outerShdw>
+          </a:effectLst>
+        </p:spPr>
+      </p:sp>
+      <p:sp>
+        <p:nvSpPr>
+          <p:cNvPr id="8" name="Shape 6"/>
+          <p:cNvSpPr/>
+          <p:nvPr/>
+        </p:nvSpPr>
+        <p:spPr>
+          <a:xfrm>
+            <a:off x="562356" y="1764792"/>
+            <a:ext cx="73152" cy="2688336"/>
           </a:xfrm>
           <a:prstGeom prst="rect">
             <a:avLst/>
@@ -6775,14 +8032,14 @@
       </p:sp>
       <p:sp>
         <p:nvSpPr>
-          <p:cNvPr id="8" name="Text 6"/>
-          <p:cNvSpPr/>
-          <p:nvPr/>
-        </p:nvSpPr>
-        <p:spPr>
-          <a:xfrm>
-            <a:off x="786384" y="1837944"/>
-            <a:ext cx="2157984" cy="384048"/>
+          <p:cNvPr id="9" name="Text 7"/>
+          <p:cNvSpPr/>
+          <p:nvPr/>
+        </p:nvSpPr>
+        <p:spPr>
+          <a:xfrm>
+            <a:off x="804672" y="1828800"/>
+            <a:ext cx="2139696" cy="384048"/>
           </a:xfrm>
           <a:prstGeom prst="rect">
             <a:avLst/>
@@ -6798,7 +8055,7 @@
               <a:buNone/>
             </a:pPr>
             <a:r>
-              <a:rPr lang="en-US" sz="1500" b="1" dirty="0">
+              <a:rPr lang="en-US" sz="1500" b="1" spc="50" kern="0" dirty="0">
                 <a:solidFill>
                   <a:srgbClr val="22D3EE"/>
                 </a:solidFill>
@@ -6814,14 +8071,34 @@
       </p:sp>
       <p:sp>
         <p:nvSpPr>
-          <p:cNvPr id="9" name="Text 7"/>
-          <p:cNvSpPr/>
-          <p:nvPr/>
-        </p:nvSpPr>
-        <p:spPr>
-          <a:xfrm>
-            <a:off x="786384" y="2276856"/>
-            <a:ext cx="2084832" cy="2103120"/>
+          <p:cNvPr id="10" name="Shape 8"/>
+          <p:cNvSpPr/>
+          <p:nvPr/>
+        </p:nvSpPr>
+        <p:spPr>
+          <a:xfrm>
+            <a:off x="804672" y="2221992"/>
+            <a:ext cx="2029968" cy="16459"/>
+          </a:xfrm>
+          <a:prstGeom prst="rect">
+            <a:avLst/>
+          </a:prstGeom>
+          <a:solidFill>
+            <a:srgbClr val="264862"/>
+          </a:solidFill>
+          <a:ln/>
+        </p:spPr>
+      </p:sp>
+      <p:sp>
+        <p:nvSpPr>
+          <p:cNvPr id="11" name="Text 9"/>
+          <p:cNvSpPr/>
+          <p:nvPr/>
+        </p:nvSpPr>
+        <p:spPr>
+          <a:xfrm>
+            <a:off x="804672" y="2331720"/>
+            <a:ext cx="2066544" cy="2048256"/>
           </a:xfrm>
           <a:prstGeom prst="rect">
             <a:avLst/>
@@ -6843,7 +8120,7 @@
             <a:r>
               <a:rPr lang="en-US" sz="1250" dirty="0">
                 <a:solidFill>
-                  <a:srgbClr val="E8EEF5"/>
+                  <a:srgbClr val="EAF1F8"/>
                 </a:solidFill>
                 <a:latin typeface="Calibri" pitchFamily="34" charset="0"/>
                 <a:ea typeface="Calibri" pitchFamily="34" charset="-122"/>
@@ -6864,7 +8141,7 @@
             <a:r>
               <a:rPr lang="en-US" sz="1250" dirty="0">
                 <a:solidFill>
-                  <a:srgbClr val="E8EEF5"/>
+                  <a:srgbClr val="EAF1F8"/>
                 </a:solidFill>
                 <a:latin typeface="Calibri" pitchFamily="34" charset="0"/>
                 <a:ea typeface="Calibri" pitchFamily="34" charset="-122"/>
@@ -6885,7 +8162,7 @@
             <a:r>
               <a:rPr lang="en-US" sz="1250" dirty="0">
                 <a:solidFill>
-                  <a:srgbClr val="E8EEF5"/>
+                  <a:srgbClr val="EAF1F8"/>
                 </a:solidFill>
                 <a:latin typeface="Calibri" pitchFamily="34" charset="0"/>
                 <a:ea typeface="Calibri" pitchFamily="34" charset="-122"/>
@@ -6899,7 +8176,7 @@
       </p:sp>
       <p:sp>
         <p:nvSpPr>
-          <p:cNvPr id="10" name="Shape 8"/>
+          <p:cNvPr id="12" name="Shape 10"/>
           <p:cNvSpPr/>
           <p:nvPr/>
         </p:nvSpPr>
@@ -6908,11 +8185,13 @@
             <a:off x="3200400" y="1691640"/>
             <a:ext cx="2542032" cy="2834640"/>
           </a:xfrm>
-          <a:prstGeom prst="rect">
-            <a:avLst/>
-          </a:prstGeom>
-          <a:solidFill>
-            <a:srgbClr val="12293D"/>
+          <a:prstGeom prst="roundRect">
+            <a:avLst>
+              <a:gd name="adj" fmla="val 1799"/>
+            </a:avLst>
+          </a:prstGeom>
+          <a:solidFill>
+            <a:srgbClr val="13283C"/>
           </a:solidFill>
           <a:ln w="15875">
             <a:solidFill>
@@ -6920,18 +8199,25 @@
             </a:solidFill>
             <a:prstDash val="solid"/>
           </a:ln>
-        </p:spPr>
-      </p:sp>
-      <p:sp>
-        <p:nvSpPr>
-          <p:cNvPr id="11" name="Shape 9"/>
-          <p:cNvSpPr/>
-          <p:nvPr/>
-        </p:nvSpPr>
-        <p:spPr>
-          <a:xfrm>
-            <a:off x="3200400" y="1691640"/>
-            <a:ext cx="82296" cy="2834640"/>
+          <a:effectLst>
+            <a:outerShdw sx="100000" sy="100000" kx="0" ky="0" algn="bl" rotWithShape="0" blurRad="88900" dist="38100" dir="5400000">
+              <a:srgbClr val="000000">
+                <a:alpha val="50000"/>
+              </a:srgbClr>
+            </a:outerShdw>
+          </a:effectLst>
+        </p:spPr>
+      </p:sp>
+      <p:sp>
+        <p:nvSpPr>
+          <p:cNvPr id="13" name="Shape 11"/>
+          <p:cNvSpPr/>
+          <p:nvPr/>
+        </p:nvSpPr>
+        <p:spPr>
+          <a:xfrm>
+            <a:off x="3214116" y="1764792"/>
+            <a:ext cx="73152" cy="2688336"/>
           </a:xfrm>
           <a:prstGeom prst="rect">
             <a:avLst/>
@@ -6944,14 +8230,14 @@
       </p:sp>
       <p:sp>
         <p:nvSpPr>
-          <p:cNvPr id="12" name="Text 10"/>
-          <p:cNvSpPr/>
-          <p:nvPr/>
-        </p:nvSpPr>
-        <p:spPr>
-          <a:xfrm>
-            <a:off x="3438144" y="1837944"/>
-            <a:ext cx="2157984" cy="384048"/>
+          <p:cNvPr id="14" name="Text 12"/>
+          <p:cNvSpPr/>
+          <p:nvPr/>
+        </p:nvSpPr>
+        <p:spPr>
+          <a:xfrm>
+            <a:off x="3456432" y="1828800"/>
+            <a:ext cx="2139696" cy="384048"/>
           </a:xfrm>
           <a:prstGeom prst="rect">
             <a:avLst/>
@@ -6967,7 +8253,7 @@
               <a:buNone/>
             </a:pPr>
             <a:r>
-              <a:rPr lang="en-US" sz="1500" b="1" dirty="0">
+              <a:rPr lang="en-US" sz="1500" b="1" spc="50" kern="0" dirty="0">
                 <a:solidFill>
                   <a:srgbClr val="34D399"/>
                 </a:solidFill>
@@ -6983,14 +8269,34 @@
       </p:sp>
       <p:sp>
         <p:nvSpPr>
-          <p:cNvPr id="13" name="Text 11"/>
-          <p:cNvSpPr/>
-          <p:nvPr/>
-        </p:nvSpPr>
-        <p:spPr>
-          <a:xfrm>
-            <a:off x="3438144" y="2276856"/>
-            <a:ext cx="2084832" cy="2103120"/>
+          <p:cNvPr id="15" name="Shape 13"/>
+          <p:cNvSpPr/>
+          <p:nvPr/>
+        </p:nvSpPr>
+        <p:spPr>
+          <a:xfrm>
+            <a:off x="3456432" y="2221992"/>
+            <a:ext cx="2029968" cy="16459"/>
+          </a:xfrm>
+          <a:prstGeom prst="rect">
+            <a:avLst/>
+          </a:prstGeom>
+          <a:solidFill>
+            <a:srgbClr val="264862"/>
+          </a:solidFill>
+          <a:ln/>
+        </p:spPr>
+      </p:sp>
+      <p:sp>
+        <p:nvSpPr>
+          <p:cNvPr id="16" name="Text 14"/>
+          <p:cNvSpPr/>
+          <p:nvPr/>
+        </p:nvSpPr>
+        <p:spPr>
+          <a:xfrm>
+            <a:off x="3456432" y="2331720"/>
+            <a:ext cx="2066544" cy="2048256"/>
           </a:xfrm>
           <a:prstGeom prst="rect">
             <a:avLst/>
@@ -7012,7 +8318,7 @@
             <a:r>
               <a:rPr lang="en-US" sz="1250" dirty="0">
                 <a:solidFill>
-                  <a:srgbClr val="E8EEF5"/>
+                  <a:srgbClr val="EAF1F8"/>
                 </a:solidFill>
                 <a:latin typeface="Calibri" pitchFamily="34" charset="0"/>
                 <a:ea typeface="Calibri" pitchFamily="34" charset="-122"/>
@@ -7033,7 +8339,7 @@
             <a:r>
               <a:rPr lang="en-US" sz="1250" dirty="0">
                 <a:solidFill>
-                  <a:srgbClr val="E8EEF5"/>
+                  <a:srgbClr val="EAF1F8"/>
                 </a:solidFill>
                 <a:latin typeface="Calibri" pitchFamily="34" charset="0"/>
                 <a:ea typeface="Calibri" pitchFamily="34" charset="-122"/>
@@ -7054,7 +8360,7 @@
             <a:r>
               <a:rPr lang="en-US" sz="1250" dirty="0">
                 <a:solidFill>
-                  <a:srgbClr val="E8EEF5"/>
+                  <a:srgbClr val="EAF1F8"/>
                 </a:solidFill>
                 <a:latin typeface="Calibri" pitchFamily="34" charset="0"/>
                 <a:ea typeface="Calibri" pitchFamily="34" charset="-122"/>
@@ -7068,7 +8374,7 @@
       </p:sp>
       <p:sp>
         <p:nvSpPr>
-          <p:cNvPr id="14" name="Shape 12"/>
+          <p:cNvPr id="17" name="Shape 15"/>
           <p:cNvSpPr/>
           <p:nvPr/>
         </p:nvSpPr>
@@ -7077,11 +8383,13 @@
             <a:off x="5669280" y="1691640"/>
             <a:ext cx="2542032" cy="2834640"/>
           </a:xfrm>
-          <a:prstGeom prst="rect">
-            <a:avLst/>
-          </a:prstGeom>
-          <a:solidFill>
-            <a:srgbClr val="12293D"/>
+          <a:prstGeom prst="roundRect">
+            <a:avLst>
+              <a:gd name="adj" fmla="val 1799"/>
+            </a:avLst>
+          </a:prstGeom>
+          <a:solidFill>
+            <a:srgbClr val="13283C"/>
           </a:solidFill>
           <a:ln w="15875">
             <a:solidFill>
@@ -7089,18 +8397,25 @@
             </a:solidFill>
             <a:prstDash val="solid"/>
           </a:ln>
-        </p:spPr>
-      </p:sp>
-      <p:sp>
-        <p:nvSpPr>
-          <p:cNvPr id="15" name="Shape 13"/>
-          <p:cNvSpPr/>
-          <p:nvPr/>
-        </p:nvSpPr>
-        <p:spPr>
-          <a:xfrm>
-            <a:off x="5669280" y="1691640"/>
-            <a:ext cx="82296" cy="2834640"/>
+          <a:effectLst>
+            <a:outerShdw sx="100000" sy="100000" kx="0" ky="0" algn="bl" rotWithShape="0" blurRad="88900" dist="38100" dir="5400000">
+              <a:srgbClr val="000000">
+                <a:alpha val="50000"/>
+              </a:srgbClr>
+            </a:outerShdw>
+          </a:effectLst>
+        </p:spPr>
+      </p:sp>
+      <p:sp>
+        <p:nvSpPr>
+          <p:cNvPr id="18" name="Shape 16"/>
+          <p:cNvSpPr/>
+          <p:nvPr/>
+        </p:nvSpPr>
+        <p:spPr>
+          <a:xfrm>
+            <a:off x="5682996" y="1764792"/>
+            <a:ext cx="73152" cy="2688336"/>
           </a:xfrm>
           <a:prstGeom prst="rect">
             <a:avLst/>
@@ -7113,14 +8428,14 @@
       </p:sp>
       <p:sp>
         <p:nvSpPr>
-          <p:cNvPr id="16" name="Text 14"/>
-          <p:cNvSpPr/>
-          <p:nvPr/>
-        </p:nvSpPr>
-        <p:spPr>
-          <a:xfrm>
-            <a:off x="5907024" y="1837944"/>
-            <a:ext cx="2157984" cy="384048"/>
+          <p:cNvPr id="19" name="Text 17"/>
+          <p:cNvSpPr/>
+          <p:nvPr/>
+        </p:nvSpPr>
+        <p:spPr>
+          <a:xfrm>
+            <a:off x="5925312" y="1828800"/>
+            <a:ext cx="2139696" cy="384048"/>
           </a:xfrm>
           <a:prstGeom prst="rect">
             <a:avLst/>
@@ -7136,7 +8451,7 @@
               <a:buNone/>
             </a:pPr>
             <a:r>
-              <a:rPr lang="en-US" sz="1500" b="1" dirty="0">
+              <a:rPr lang="en-US" sz="1500" b="1" spc="50" kern="0" dirty="0">
                 <a:solidFill>
                   <a:srgbClr val="FBBF24"/>
                 </a:solidFill>
@@ -7152,14 +8467,34 @@
       </p:sp>
       <p:sp>
         <p:nvSpPr>
-          <p:cNvPr id="17" name="Text 15"/>
-          <p:cNvSpPr/>
-          <p:nvPr/>
-        </p:nvSpPr>
-        <p:spPr>
-          <a:xfrm>
-            <a:off x="5907024" y="2276856"/>
-            <a:ext cx="2084832" cy="2103120"/>
+          <p:cNvPr id="20" name="Shape 18"/>
+          <p:cNvSpPr/>
+          <p:nvPr/>
+        </p:nvSpPr>
+        <p:spPr>
+          <a:xfrm>
+            <a:off x="5925312" y="2221992"/>
+            <a:ext cx="2029968" cy="16459"/>
+          </a:xfrm>
+          <a:prstGeom prst="rect">
+            <a:avLst/>
+          </a:prstGeom>
+          <a:solidFill>
+            <a:srgbClr val="264862"/>
+          </a:solidFill>
+          <a:ln/>
+        </p:spPr>
+      </p:sp>
+      <p:sp>
+        <p:nvSpPr>
+          <p:cNvPr id="21" name="Text 19"/>
+          <p:cNvSpPr/>
+          <p:nvPr/>
+        </p:nvSpPr>
+        <p:spPr>
+          <a:xfrm>
+            <a:off x="5925312" y="2331720"/>
+            <a:ext cx="2066544" cy="2048256"/>
           </a:xfrm>
           <a:prstGeom prst="rect">
             <a:avLst/>
@@ -7181,7 +8516,7 @@
             <a:r>
               <a:rPr lang="en-US" sz="1250" dirty="0">
                 <a:solidFill>
-                  <a:srgbClr val="E8EEF5"/>
+                  <a:srgbClr val="EAF1F8"/>
                 </a:solidFill>
                 <a:latin typeface="Calibri" pitchFamily="34" charset="0"/>
                 <a:ea typeface="Calibri" pitchFamily="34" charset="-122"/>
@@ -7202,7 +8537,7 @@
             <a:r>
               <a:rPr lang="en-US" sz="1250" dirty="0">
                 <a:solidFill>
-                  <a:srgbClr val="E8EEF5"/>
+                  <a:srgbClr val="EAF1F8"/>
                 </a:solidFill>
                 <a:latin typeface="Calibri" pitchFamily="34" charset="0"/>
                 <a:ea typeface="Calibri" pitchFamily="34" charset="-122"/>
@@ -7223,7 +8558,7 @@
             <a:r>
               <a:rPr lang="en-US" sz="1250" dirty="0">
                 <a:solidFill>
-                  <a:srgbClr val="E8EEF5"/>
+                  <a:srgbClr val="EAF1F8"/>
                 </a:solidFill>
                 <a:latin typeface="Calibri" pitchFamily="34" charset="0"/>
                 <a:ea typeface="Calibri" pitchFamily="34" charset="-122"/>
@@ -7249,7 +8584,7 @@
     <p:bg>
       <p:bgPr>
         <a:solidFill>
-          <a:srgbClr val="0B1B2B"/>
+          <a:srgbClr val="0A1622"/>
         </a:solidFill>
       </p:bgPr>
     </p:bg>
@@ -7287,6 +8622,13 @@
             <a:srgbClr val="22D3EE"/>
           </a:solidFill>
           <a:ln/>
+          <a:effectLst>
+            <a:outerShdw sx="100000" sy="100000" kx="0" ky="0" algn="bl" rotWithShape="0" blurRad="50800" dist="25400" dir="5400000">
+              <a:srgbClr val="000000">
+                <a:alpha val="40000"/>
+              </a:srgbClr>
+            </a:outerShdw>
+          </a:effectLst>
         </p:spPr>
       </p:sp>
       <p:sp>
@@ -7316,7 +8658,7 @@
             <a:r>
               <a:rPr lang="en-US" sz="2200" b="1" dirty="0">
                 <a:solidFill>
-                  <a:srgbClr val="0B1B2B"/>
+                  <a:srgbClr val="0A1622"/>
                 </a:solidFill>
                 <a:latin typeface="Consolas" pitchFamily="34" charset="0"/>
                 <a:ea typeface="Consolas" pitchFamily="34" charset="-122"/>
@@ -7408,7 +8750,27 @@
       </p:sp>
       <p:sp>
         <p:nvSpPr>
-          <p:cNvPr id="6" name="Text 4"/>
+          <p:cNvPr id="6" name="Shape 4"/>
+          <p:cNvSpPr/>
+          <p:nvPr/>
+        </p:nvSpPr>
+        <p:spPr>
+          <a:xfrm>
+            <a:off x="1298448" y="1316736"/>
+            <a:ext cx="1005840" cy="32004"/>
+          </a:xfrm>
+          <a:prstGeom prst="rect">
+            <a:avLst/>
+          </a:prstGeom>
+          <a:solidFill>
+            <a:srgbClr val="22D3EE"/>
+          </a:solidFill>
+          <a:ln/>
+        </p:spPr>
+      </p:sp>
+      <p:sp>
+        <p:nvSpPr>
+          <p:cNvPr id="7" name="Text 5"/>
           <p:cNvSpPr/>
           <p:nvPr/>
         </p:nvSpPr>
@@ -7437,7 +8799,7 @@
             <a:r>
               <a:rPr lang="en-US" sz="1600" dirty="0">
                 <a:solidFill>
-                  <a:srgbClr val="E8EEF5"/>
+                  <a:srgbClr val="EAF1F8"/>
                 </a:solidFill>
                 <a:latin typeface="Calibri" pitchFamily="34" charset="0"/>
                 <a:ea typeface="Calibri" pitchFamily="34" charset="-122"/>
@@ -7458,7 +8820,7 @@
             <a:r>
               <a:rPr lang="en-US" sz="1600" dirty="0">
                 <a:solidFill>
-                  <a:srgbClr val="E8EEF5"/>
+                  <a:srgbClr val="EAF1F8"/>
                 </a:solidFill>
                 <a:latin typeface="Calibri" pitchFamily="34" charset="0"/>
                 <a:ea typeface="Calibri" pitchFamily="34" charset="-122"/>
@@ -7479,7 +8841,7 @@
             <a:r>
               <a:rPr lang="en-US" sz="1600" dirty="0">
                 <a:solidFill>
-                  <a:srgbClr val="E8EEF5"/>
+                  <a:srgbClr val="EAF1F8"/>
                 </a:solidFill>
                 <a:latin typeface="Calibri" pitchFamily="34" charset="0"/>
                 <a:ea typeface="Calibri" pitchFamily="34" charset="-122"/>
@@ -7493,7 +8855,7 @@
       </p:sp>
       <p:sp>
         <p:nvSpPr>
-          <p:cNvPr id="7" name="Shape 5"/>
+          <p:cNvPr id="8" name="Shape 6"/>
           <p:cNvSpPr/>
           <p:nvPr/>
         </p:nvSpPr>
@@ -7502,30 +8864,119 @@
             <a:off x="548640" y="3154680"/>
             <a:ext cx="8046720" cy="1463040"/>
           </a:xfrm>
-          <a:prstGeom prst="rect">
-            <a:avLst/>
-          </a:prstGeom>
-          <a:solidFill>
-            <a:srgbClr val="081320"/>
+          <a:prstGeom prst="roundRect">
+            <a:avLst>
+              <a:gd name="adj" fmla="val 2188"/>
+            </a:avLst>
+          </a:prstGeom>
+          <a:solidFill>
+            <a:srgbClr val="060F1A"/>
           </a:solidFill>
           <a:ln w="12700">
             <a:solidFill>
-              <a:srgbClr val="284963"/>
+              <a:srgbClr val="264862"/>
             </a:solidFill>
             <a:prstDash val="solid"/>
           </a:ln>
-        </p:spPr>
-      </p:sp>
-      <p:sp>
-        <p:nvSpPr>
-          <p:cNvPr id="8" name="Text 6"/>
-          <p:cNvSpPr/>
-          <p:nvPr/>
-        </p:nvSpPr>
-        <p:spPr>
-          <a:xfrm>
-            <a:off x="749808" y="3282696"/>
-            <a:ext cx="7644384" cy="1207008"/>
+          <a:effectLst>
+            <a:outerShdw sx="100000" sy="100000" kx="0" ky="0" algn="bl" rotWithShape="0" blurRad="88900" dist="38100" dir="5400000">
+              <a:srgbClr val="000000">
+                <a:alpha val="50000"/>
+              </a:srgbClr>
+            </a:outerShdw>
+          </a:effectLst>
+        </p:spPr>
+      </p:sp>
+      <p:sp>
+        <p:nvSpPr>
+          <p:cNvPr id="9" name="Shape 7"/>
+          <p:cNvSpPr/>
+          <p:nvPr/>
+        </p:nvSpPr>
+        <p:spPr>
+          <a:xfrm>
+            <a:off x="566928" y="3191256"/>
+            <a:ext cx="8010144" cy="274320"/>
+          </a:xfrm>
+          <a:prstGeom prst="rect">
+            <a:avLst/>
+          </a:prstGeom>
+          <a:solidFill>
+            <a:srgbClr val="13283C"/>
+          </a:solidFill>
+          <a:ln/>
+        </p:spPr>
+      </p:sp>
+      <p:sp>
+        <p:nvSpPr>
+          <p:cNvPr id="10" name="Shape 8"/>
+          <p:cNvSpPr/>
+          <p:nvPr/>
+        </p:nvSpPr>
+        <p:spPr>
+          <a:xfrm>
+            <a:off x="713232" y="3264408"/>
+            <a:ext cx="118872" cy="118872"/>
+          </a:xfrm>
+          <a:prstGeom prst="ellipse">
+            <a:avLst/>
+          </a:prstGeom>
+          <a:solidFill>
+            <a:srgbClr val="FB7185"/>
+          </a:solidFill>
+          <a:ln/>
+        </p:spPr>
+      </p:sp>
+      <p:sp>
+        <p:nvSpPr>
+          <p:cNvPr id="11" name="Shape 9"/>
+          <p:cNvSpPr/>
+          <p:nvPr/>
+        </p:nvSpPr>
+        <p:spPr>
+          <a:xfrm>
+            <a:off x="886968" y="3264408"/>
+            <a:ext cx="118872" cy="118872"/>
+          </a:xfrm>
+          <a:prstGeom prst="ellipse">
+            <a:avLst/>
+          </a:prstGeom>
+          <a:solidFill>
+            <a:srgbClr val="FBBF24"/>
+          </a:solidFill>
+          <a:ln/>
+        </p:spPr>
+      </p:sp>
+      <p:sp>
+        <p:nvSpPr>
+          <p:cNvPr id="12" name="Shape 10"/>
+          <p:cNvSpPr/>
+          <p:nvPr/>
+        </p:nvSpPr>
+        <p:spPr>
+          <a:xfrm>
+            <a:off x="1060704" y="3264408"/>
+            <a:ext cx="118872" cy="118872"/>
+          </a:xfrm>
+          <a:prstGeom prst="ellipse">
+            <a:avLst/>
+          </a:prstGeom>
+          <a:solidFill>
+            <a:srgbClr val="34D399"/>
+          </a:solidFill>
+          <a:ln/>
+        </p:spPr>
+      </p:sp>
+      <p:sp>
+        <p:nvSpPr>
+          <p:cNvPr id="13" name="Text 11"/>
+          <p:cNvSpPr/>
+          <p:nvPr/>
+        </p:nvSpPr>
+        <p:spPr>
+          <a:xfrm>
+            <a:off x="768096" y="3575304"/>
+            <a:ext cx="7626096" cy="914400"/>
           </a:xfrm>
           <a:prstGeom prst="rect">
             <a:avLst/>
@@ -7620,7 +9071,7 @@
     <p:bg>
       <p:bgPr>
         <a:solidFill>
-          <a:srgbClr val="0B1B2B"/>
+          <a:srgbClr val="0A1622"/>
         </a:solidFill>
       </p:bgPr>
     </p:bg>
@@ -7658,6 +9109,13 @@
             <a:srgbClr val="22D3EE"/>
           </a:solidFill>
           <a:ln/>
+          <a:effectLst>
+            <a:outerShdw sx="100000" sy="100000" kx="0" ky="0" algn="bl" rotWithShape="0" blurRad="50800" dist="25400" dir="5400000">
+              <a:srgbClr val="000000">
+                <a:alpha val="40000"/>
+              </a:srgbClr>
+            </a:outerShdw>
+          </a:effectLst>
         </p:spPr>
       </p:sp>
       <p:sp>
@@ -7687,7 +9145,7 @@
             <a:r>
               <a:rPr lang="en-US" sz="2200" b="1" dirty="0">
                 <a:solidFill>
-                  <a:srgbClr val="0B1B2B"/>
+                  <a:srgbClr val="0A1622"/>
                 </a:solidFill>
                 <a:latin typeface="Consolas" pitchFamily="34" charset="0"/>
                 <a:ea typeface="Consolas" pitchFamily="34" charset="-122"/>
@@ -7779,7 +9237,27 @@
       </p:sp>
       <p:sp>
         <p:nvSpPr>
-          <p:cNvPr id="6" name="Text 4"/>
+          <p:cNvPr id="6" name="Shape 4"/>
+          <p:cNvSpPr/>
+          <p:nvPr/>
+        </p:nvSpPr>
+        <p:spPr>
+          <a:xfrm>
+            <a:off x="1298448" y="1316736"/>
+            <a:ext cx="1005840" cy="32004"/>
+          </a:xfrm>
+          <a:prstGeom prst="rect">
+            <a:avLst/>
+          </a:prstGeom>
+          <a:solidFill>
+            <a:srgbClr val="22D3EE"/>
+          </a:solidFill>
+          <a:ln/>
+        </p:spPr>
+      </p:sp>
+      <p:sp>
+        <p:nvSpPr>
+          <p:cNvPr id="7" name="Text 5"/>
           <p:cNvSpPr/>
           <p:nvPr/>
         </p:nvSpPr>
@@ -7808,7 +9286,7 @@
             <a:r>
               <a:rPr lang="en-US" sz="1600" b="1" dirty="0">
                 <a:solidFill>
-                  <a:srgbClr val="E8EEF5"/>
+                  <a:srgbClr val="EAF1F8"/>
                 </a:solidFill>
                 <a:latin typeface="Calibri" pitchFamily="34" charset="0"/>
                 <a:ea typeface="Calibri" pitchFamily="34" charset="-122"/>
@@ -7829,7 +9307,7 @@
             <a:r>
               <a:rPr lang="en-US" sz="1600" dirty="0">
                 <a:solidFill>
-                  <a:srgbClr val="E8EEF5"/>
+                  <a:srgbClr val="EAF1F8"/>
                 </a:solidFill>
                 <a:latin typeface="Calibri" pitchFamily="34" charset="0"/>
                 <a:ea typeface="Calibri" pitchFamily="34" charset="-122"/>
@@ -7850,7 +9328,7 @@
             <a:r>
               <a:rPr lang="en-US" sz="1600" dirty="0">
                 <a:solidFill>
-                  <a:srgbClr val="E8EEF5"/>
+                  <a:srgbClr val="EAF1F8"/>
                 </a:solidFill>
                 <a:latin typeface="Calibri" pitchFamily="34" charset="0"/>
                 <a:ea typeface="Calibri" pitchFamily="34" charset="-122"/>
@@ -7871,7 +9349,7 @@
             <a:r>
               <a:rPr lang="en-US" sz="1600" dirty="0">
                 <a:solidFill>
-                  <a:srgbClr val="E8EEF5"/>
+                  <a:srgbClr val="EAF1F8"/>
                 </a:solidFill>
                 <a:latin typeface="Calibri" pitchFamily="34" charset="0"/>
                 <a:ea typeface="Calibri" pitchFamily="34" charset="-122"/>
@@ -7897,7 +9375,7 @@
     <p:bg>
       <p:bgPr>
         <a:solidFill>
-          <a:srgbClr val="0B1B2B"/>
+          <a:srgbClr val="0A1622"/>
         </a:solidFill>
       </p:bgPr>
     </p:bg>
@@ -7935,6 +9413,13 @@
             <a:srgbClr val="22D3EE"/>
           </a:solidFill>
           <a:ln/>
+          <a:effectLst>
+            <a:outerShdw sx="100000" sy="100000" kx="0" ky="0" algn="bl" rotWithShape="0" blurRad="50800" dist="25400" dir="5400000">
+              <a:srgbClr val="000000">
+                <a:alpha val="40000"/>
+              </a:srgbClr>
+            </a:outerShdw>
+          </a:effectLst>
         </p:spPr>
       </p:sp>
       <p:sp>
@@ -7964,7 +9449,7 @@
             <a:r>
               <a:rPr lang="en-US" sz="2200" b="1" dirty="0">
                 <a:solidFill>
-                  <a:srgbClr val="0B1B2B"/>
+                  <a:srgbClr val="0A1622"/>
                 </a:solidFill>
                 <a:latin typeface="Consolas" pitchFamily="34" charset="0"/>
                 <a:ea typeface="Consolas" pitchFamily="34" charset="-122"/>
@@ -8062,14 +9547,36 @@
         </p:nvSpPr>
         <p:spPr>
           <a:xfrm>
+            <a:off x="1298448" y="1316736"/>
+            <a:ext cx="1005840" cy="32004"/>
+          </a:xfrm>
+          <a:prstGeom prst="rect">
+            <a:avLst/>
+          </a:prstGeom>
+          <a:solidFill>
+            <a:srgbClr val="22D3EE"/>
+          </a:solidFill>
+          <a:ln/>
+        </p:spPr>
+      </p:sp>
+      <p:sp>
+        <p:nvSpPr>
+          <p:cNvPr id="7" name="Shape 5"/>
+          <p:cNvSpPr/>
+          <p:nvPr/>
+        </p:nvSpPr>
+        <p:spPr>
+          <a:xfrm>
             <a:off x="548640" y="1691640"/>
             <a:ext cx="3886200" cy="2743200"/>
           </a:xfrm>
-          <a:prstGeom prst="rect">
-            <a:avLst/>
-          </a:prstGeom>
-          <a:solidFill>
-            <a:srgbClr val="12293D"/>
+          <a:prstGeom prst="roundRect">
+            <a:avLst>
+              <a:gd name="adj" fmla="val 1667"/>
+            </a:avLst>
+          </a:prstGeom>
+          <a:solidFill>
+            <a:srgbClr val="13283C"/>
           </a:solidFill>
           <a:ln w="15875">
             <a:solidFill>
@@ -8077,18 +9584,25 @@
             </a:solidFill>
             <a:prstDash val="solid"/>
           </a:ln>
-        </p:spPr>
-      </p:sp>
-      <p:sp>
-        <p:nvSpPr>
-          <p:cNvPr id="7" name="Shape 5"/>
-          <p:cNvSpPr/>
-          <p:nvPr/>
-        </p:nvSpPr>
-        <p:spPr>
-          <a:xfrm>
-            <a:off x="548640" y="1691640"/>
-            <a:ext cx="82296" cy="2743200"/>
+          <a:effectLst>
+            <a:outerShdw sx="100000" sy="100000" kx="0" ky="0" algn="bl" rotWithShape="0" blurRad="88900" dist="38100" dir="5400000">
+              <a:srgbClr val="000000">
+                <a:alpha val="50000"/>
+              </a:srgbClr>
+            </a:outerShdw>
+          </a:effectLst>
+        </p:spPr>
+      </p:sp>
+      <p:sp>
+        <p:nvSpPr>
+          <p:cNvPr id="8" name="Shape 6"/>
+          <p:cNvSpPr/>
+          <p:nvPr/>
+        </p:nvSpPr>
+        <p:spPr>
+          <a:xfrm>
+            <a:off x="562356" y="1764792"/>
+            <a:ext cx="73152" cy="2596896"/>
           </a:xfrm>
           <a:prstGeom prst="rect">
             <a:avLst/>
@@ -8101,14 +9615,14 @@
       </p:sp>
       <p:sp>
         <p:nvSpPr>
-          <p:cNvPr id="8" name="Text 6"/>
-          <p:cNvSpPr/>
-          <p:nvPr/>
-        </p:nvSpPr>
-        <p:spPr>
-          <a:xfrm>
-            <a:off x="786384" y="1837944"/>
-            <a:ext cx="3502152" cy="384048"/>
+          <p:cNvPr id="9" name="Text 7"/>
+          <p:cNvSpPr/>
+          <p:nvPr/>
+        </p:nvSpPr>
+        <p:spPr>
+          <a:xfrm>
+            <a:off x="804672" y="1828800"/>
+            <a:ext cx="3483864" cy="384048"/>
           </a:xfrm>
           <a:prstGeom prst="rect">
             <a:avLst/>
@@ -8124,7 +9638,7 @@
               <a:buNone/>
             </a:pPr>
             <a:r>
-              <a:rPr lang="en-US" sz="1500" b="1" dirty="0">
+              <a:rPr lang="en-US" sz="1500" b="1" spc="50" kern="0" dirty="0">
                 <a:solidFill>
                   <a:srgbClr val="22D3EE"/>
                 </a:solidFill>
@@ -8140,14 +9654,34 @@
       </p:sp>
       <p:sp>
         <p:nvSpPr>
-          <p:cNvPr id="9" name="Text 7"/>
-          <p:cNvSpPr/>
-          <p:nvPr/>
-        </p:nvSpPr>
-        <p:spPr>
-          <a:xfrm>
-            <a:off x="786384" y="2276856"/>
-            <a:ext cx="3429000" cy="2011680"/>
+          <p:cNvPr id="10" name="Shape 8"/>
+          <p:cNvSpPr/>
+          <p:nvPr/>
+        </p:nvSpPr>
+        <p:spPr>
+          <a:xfrm>
+            <a:off x="804672" y="2221992"/>
+            <a:ext cx="3374136" cy="16459"/>
+          </a:xfrm>
+          <a:prstGeom prst="rect">
+            <a:avLst/>
+          </a:prstGeom>
+          <a:solidFill>
+            <a:srgbClr val="264862"/>
+          </a:solidFill>
+          <a:ln/>
+        </p:spPr>
+      </p:sp>
+      <p:sp>
+        <p:nvSpPr>
+          <p:cNvPr id="11" name="Text 9"/>
+          <p:cNvSpPr/>
+          <p:nvPr/>
+        </p:nvSpPr>
+        <p:spPr>
+          <a:xfrm>
+            <a:off x="804672" y="2331720"/>
+            <a:ext cx="3410712" cy="1956816"/>
           </a:xfrm>
           <a:prstGeom prst="rect">
             <a:avLst/>
@@ -8169,7 +9703,7 @@
             <a:r>
               <a:rPr lang="en-US" sz="1250" dirty="0">
                 <a:solidFill>
-                  <a:srgbClr val="E8EEF5"/>
+                  <a:srgbClr val="EAF1F8"/>
                 </a:solidFill>
                 <a:latin typeface="Calibri" pitchFamily="34" charset="0"/>
                 <a:ea typeface="Calibri" pitchFamily="34" charset="-122"/>
@@ -8190,7 +9724,7 @@
             <a:r>
               <a:rPr lang="en-US" sz="1250" dirty="0">
                 <a:solidFill>
-                  <a:srgbClr val="E8EEF5"/>
+                  <a:srgbClr val="EAF1F8"/>
                 </a:solidFill>
                 <a:latin typeface="Calibri" pitchFamily="34" charset="0"/>
                 <a:ea typeface="Calibri" pitchFamily="34" charset="-122"/>
@@ -8211,7 +9745,7 @@
             <a:r>
               <a:rPr lang="en-US" sz="1250" dirty="0">
                 <a:solidFill>
-                  <a:srgbClr val="E8EEF5"/>
+                  <a:srgbClr val="EAF1F8"/>
                 </a:solidFill>
                 <a:latin typeface="Calibri" pitchFamily="34" charset="0"/>
                 <a:ea typeface="Calibri" pitchFamily="34" charset="-122"/>
@@ -8225,7 +9759,7 @@
       </p:sp>
       <p:sp>
         <p:nvSpPr>
-          <p:cNvPr id="10" name="Shape 8"/>
+          <p:cNvPr id="12" name="Shape 10"/>
           <p:cNvSpPr/>
           <p:nvPr/>
         </p:nvSpPr>
@@ -8234,11 +9768,13 @@
             <a:off x="4663440" y="1691640"/>
             <a:ext cx="3931920" cy="2743200"/>
           </a:xfrm>
-          <a:prstGeom prst="rect">
-            <a:avLst/>
-          </a:prstGeom>
-          <a:solidFill>
-            <a:srgbClr val="12293D"/>
+          <a:prstGeom prst="roundRect">
+            <a:avLst>
+              <a:gd name="adj" fmla="val 1667"/>
+            </a:avLst>
+          </a:prstGeom>
+          <a:solidFill>
+            <a:srgbClr val="13283C"/>
           </a:solidFill>
           <a:ln w="15875">
             <a:solidFill>
@@ -8246,18 +9782,25 @@
             </a:solidFill>
             <a:prstDash val="solid"/>
           </a:ln>
-        </p:spPr>
-      </p:sp>
-      <p:sp>
-        <p:nvSpPr>
-          <p:cNvPr id="11" name="Shape 9"/>
-          <p:cNvSpPr/>
-          <p:nvPr/>
-        </p:nvSpPr>
-        <p:spPr>
-          <a:xfrm>
-            <a:off x="4663440" y="1691640"/>
-            <a:ext cx="82296" cy="2743200"/>
+          <a:effectLst>
+            <a:outerShdw sx="100000" sy="100000" kx="0" ky="0" algn="bl" rotWithShape="0" blurRad="88900" dist="38100" dir="5400000">
+              <a:srgbClr val="000000">
+                <a:alpha val="50000"/>
+              </a:srgbClr>
+            </a:outerShdw>
+          </a:effectLst>
+        </p:spPr>
+      </p:sp>
+      <p:sp>
+        <p:nvSpPr>
+          <p:cNvPr id="13" name="Shape 11"/>
+          <p:cNvSpPr/>
+          <p:nvPr/>
+        </p:nvSpPr>
+        <p:spPr>
+          <a:xfrm>
+            <a:off x="4677156" y="1764792"/>
+            <a:ext cx="73152" cy="2596896"/>
           </a:xfrm>
           <a:prstGeom prst="rect">
             <a:avLst/>
@@ -8270,14 +9813,14 @@
       </p:sp>
       <p:sp>
         <p:nvSpPr>
-          <p:cNvPr id="12" name="Text 10"/>
-          <p:cNvSpPr/>
-          <p:nvPr/>
-        </p:nvSpPr>
-        <p:spPr>
-          <a:xfrm>
-            <a:off x="4901184" y="1837944"/>
-            <a:ext cx="3547872" cy="384048"/>
+          <p:cNvPr id="14" name="Text 12"/>
+          <p:cNvSpPr/>
+          <p:nvPr/>
+        </p:nvSpPr>
+        <p:spPr>
+          <a:xfrm>
+            <a:off x="4919472" y="1828800"/>
+            <a:ext cx="3529584" cy="384048"/>
           </a:xfrm>
           <a:prstGeom prst="rect">
             <a:avLst/>
@@ -8293,7 +9836,7 @@
               <a:buNone/>
             </a:pPr>
             <a:r>
-              <a:rPr lang="en-US" sz="1500" b="1" dirty="0">
+              <a:rPr lang="en-US" sz="1500" b="1" spc="50" kern="0" dirty="0">
                 <a:solidFill>
                   <a:srgbClr val="34D399"/>
                 </a:solidFill>
@@ -8309,14 +9852,34 @@
       </p:sp>
       <p:sp>
         <p:nvSpPr>
-          <p:cNvPr id="13" name="Text 11"/>
-          <p:cNvSpPr/>
-          <p:nvPr/>
-        </p:nvSpPr>
-        <p:spPr>
-          <a:xfrm>
-            <a:off x="4901184" y="2276856"/>
-            <a:ext cx="3474720" cy="2011680"/>
+          <p:cNvPr id="15" name="Shape 13"/>
+          <p:cNvSpPr/>
+          <p:nvPr/>
+        </p:nvSpPr>
+        <p:spPr>
+          <a:xfrm>
+            <a:off x="4919472" y="2221992"/>
+            <a:ext cx="3419856" cy="16459"/>
+          </a:xfrm>
+          <a:prstGeom prst="rect">
+            <a:avLst/>
+          </a:prstGeom>
+          <a:solidFill>
+            <a:srgbClr val="264862"/>
+          </a:solidFill>
+          <a:ln/>
+        </p:spPr>
+      </p:sp>
+      <p:sp>
+        <p:nvSpPr>
+          <p:cNvPr id="16" name="Text 14"/>
+          <p:cNvSpPr/>
+          <p:nvPr/>
+        </p:nvSpPr>
+        <p:spPr>
+          <a:xfrm>
+            <a:off x="4919472" y="2331720"/>
+            <a:ext cx="3456432" cy="1956816"/>
           </a:xfrm>
           <a:prstGeom prst="rect">
             <a:avLst/>
@@ -8338,7 +9901,7 @@
             <a:r>
               <a:rPr lang="en-US" sz="1250" dirty="0">
                 <a:solidFill>
-                  <a:srgbClr val="E8EEF5"/>
+                  <a:srgbClr val="EAF1F8"/>
                 </a:solidFill>
                 <a:latin typeface="Calibri" pitchFamily="34" charset="0"/>
                 <a:ea typeface="Calibri" pitchFamily="34" charset="-122"/>
@@ -8359,7 +9922,7 @@
             <a:r>
               <a:rPr lang="en-US" sz="1250" dirty="0">
                 <a:solidFill>
-                  <a:srgbClr val="E8EEF5"/>
+                  <a:srgbClr val="EAF1F8"/>
                 </a:solidFill>
                 <a:latin typeface="Calibri" pitchFamily="34" charset="0"/>
                 <a:ea typeface="Calibri" pitchFamily="34" charset="-122"/>
@@ -8380,7 +9943,7 @@
             <a:r>
               <a:rPr lang="en-US" sz="1250" dirty="0">
                 <a:solidFill>
-                  <a:srgbClr val="E8EEF5"/>
+                  <a:srgbClr val="EAF1F8"/>
                 </a:solidFill>
                 <a:latin typeface="Calibri" pitchFamily="34" charset="0"/>
                 <a:ea typeface="Calibri" pitchFamily="34" charset="-122"/>

</xml_diff>